<commit_message>
feat(post-quantum-cryptography): update formatting for 4th lab
</commit_message>
<xml_diff>
--- a/Year 1/Постквантова криптографія/UA/2026/PPT/Презентація_4.pptx
+++ b/Year 1/Постквантова криптографія/UA/2026/PPT/Презентація_4.pptx
@@ -1268,7 +1268,7 @@
           <a:p>
             <a:fld id="{B0E38C6A-C972-4D9E-AA74-333EB6C38D98}" type="datetimeFigureOut">
               <a:rPr lang="en-US" smtClean="0"/>
-              <a:t>4/18/26</a:t>
+              <a:t>5/4/26</a:t>
             </a:fld>
             <a:endParaRPr lang="en-US"/>
           </a:p>
@@ -1872,10 +1872,10 @@
             </a:pathLst>
           </a:custGeom>
           <a:blipFill>
-            <a:blip r:embed="rId2">
+            <a:blip>
               <a:extLst>
                 <a:ext uri="{96DAC541-7B7A-43D3-8B79-37D633B846F1}">
-                  <asvg:svgBlip xmlns:asvg="http://schemas.microsoft.com/office/drawing/2016/SVG/main" r:embed="rId3"/>
+                  <asvg:svgBlip xmlns:asvg="http://schemas.microsoft.com/office/drawing/2016/SVG/main" r:embed="rId2"/>
                 </a:ext>
               </a:extLst>
             </a:blip>
@@ -2042,7 +2042,7 @@
             </a:pathLst>
           </a:custGeom>
           <a:blipFill>
-            <a:blip r:embed="rId4"/>
+            <a:blip r:embed="rId3"/>
             <a:stretch>
               <a:fillRect/>
             </a:stretch>
@@ -2124,10 +2124,10 @@
             </a:pathLst>
           </a:custGeom>
           <a:blipFill>
-            <a:blip r:embed="rId2">
+            <a:blip>
               <a:extLst>
                 <a:ext uri="{96DAC541-7B7A-43D3-8B79-37D633B846F1}">
-                  <asvg:svgBlip xmlns:asvg="http://schemas.microsoft.com/office/drawing/2016/SVG/main" r:embed="rId3"/>
+                  <asvg:svgBlip xmlns:asvg="http://schemas.microsoft.com/office/drawing/2016/SVG/main" r:embed="rId2"/>
                 </a:ext>
               </a:extLst>
             </a:blip>
@@ -2448,10 +2448,10 @@
             </a:pathLst>
           </a:custGeom>
           <a:blipFill>
-            <a:blip r:embed="rId2">
+            <a:blip>
               <a:extLst>
                 <a:ext uri="{96DAC541-7B7A-43D3-8B79-37D633B846F1}">
-                  <asvg:svgBlip xmlns:asvg="http://schemas.microsoft.com/office/drawing/2016/SVG/main" r:embed="rId3"/>
+                  <asvg:svgBlip xmlns:asvg="http://schemas.microsoft.com/office/drawing/2016/SVG/main" r:embed="rId2"/>
                 </a:ext>
               </a:extLst>
             </a:blip>
@@ -2913,10 +2913,10 @@
             </a:pathLst>
           </a:custGeom>
           <a:blipFill>
-            <a:blip r:embed="rId2">
+            <a:blip>
               <a:extLst>
                 <a:ext uri="{96DAC541-7B7A-43D3-8B79-37D633B846F1}">
-                  <asvg:svgBlip xmlns:asvg="http://schemas.microsoft.com/office/drawing/2016/SVG/main" r:embed="rId3"/>
+                  <asvg:svgBlip xmlns:asvg="http://schemas.microsoft.com/office/drawing/2016/SVG/main" r:embed="rId2"/>
                 </a:ext>
               </a:extLst>
             </a:blip>
@@ -3148,10 +3148,10 @@
             </a:pathLst>
           </a:custGeom>
           <a:blipFill>
-            <a:blip r:embed="rId2">
+            <a:blip>
               <a:extLst>
                 <a:ext uri="{96DAC541-7B7A-43D3-8B79-37D633B846F1}">
-                  <asvg:svgBlip xmlns:asvg="http://schemas.microsoft.com/office/drawing/2016/SVG/main" r:embed="rId3"/>
+                  <asvg:svgBlip xmlns:asvg="http://schemas.microsoft.com/office/drawing/2016/SVG/main" r:embed="rId2"/>
                 </a:ext>
               </a:extLst>
             </a:blip>
@@ -3489,7 +3489,7 @@
           <a:p>
             <a:fld id="{22B528A8-01FA-4E19-966E-6D8EBDB87570}" type="datetimeFigureOut">
               <a:rPr lang="uk-UA" smtClean="0"/>
-              <a:t>18.04.26</a:t>
+              <a:t>04.05.26</a:t>
             </a:fld>
             <a:endParaRPr lang="uk-UA"/>
           </a:p>
@@ -4108,7 +4108,9 @@
           </a:xfrm>
         </p:spPr>
         <p:txBody>
-          <a:bodyPr wrap="none"/>
+          <a:bodyPr wrap="none">
+            <a:normAutofit fontScale="90000"/>
+          </a:bodyPr>
           <a:lstStyle/>
           <a:p>
             <a:endParaRPr/>
@@ -4132,7 +4134,9 @@
           </a:xfrm>
         </p:spPr>
         <p:txBody>
-          <a:bodyPr wrap="none"/>
+          <a:bodyPr wrap="none">
+            <a:normAutofit fontScale="25000" lnSpcReduction="20000"/>
+          </a:bodyPr>
           <a:lstStyle/>
           <a:p>
             <a:endParaRPr/>
@@ -4156,7 +4160,9 @@
           </a:xfrm>
         </p:spPr>
         <p:txBody>
-          <a:bodyPr wrap="none"/>
+          <a:bodyPr wrap="none">
+            <a:normAutofit fontScale="25000" lnSpcReduction="20000"/>
+          </a:bodyPr>
           <a:lstStyle/>
           <a:p>
             <a:endParaRPr/>
@@ -4180,7 +4186,9 @@
           </a:xfrm>
         </p:spPr>
         <p:txBody>
-          <a:bodyPr wrap="none"/>
+          <a:bodyPr wrap="none">
+            <a:normAutofit fontScale="25000" lnSpcReduction="20000"/>
+          </a:bodyPr>
           <a:lstStyle/>
           <a:p>
             <a:endParaRPr/>
@@ -4264,24 +4272,66 @@
           <a:p>
             <a:pPr algn="ctr"/>
             <a:r>
-              <a:rPr sz="1400" b="1">
+              <a:rPr sz="1600" b="1" dirty="0">
                 <a:solidFill>
                   <a:srgbClr val="FFFFFF"/>
                 </a:solidFill>
               </a:rPr>
-              <a:t>1. Підготовка</a:t>
-            </a:r>
+              <a:t>1. </a:t>
+            </a:r>
+            <a:r>
+              <a:rPr sz="1600" b="1" dirty="0" err="1">
+                <a:solidFill>
+                  <a:srgbClr val="FFFFFF"/>
+                </a:solidFill>
+              </a:rPr>
+              <a:t>Підготовка</a:t>
+            </a:r>
+            <a:endParaRPr sz="1600" b="1" dirty="0">
+              <a:solidFill>
+                <a:srgbClr val="FFFFFF"/>
+              </a:solidFill>
+            </a:endParaRPr>
           </a:p>
           <a:p>
             <a:pPr algn="ctr"/>
             <a:r>
-              <a:rPr sz="1000">
+              <a:rPr sz="1600" dirty="0">
                 <a:solidFill>
                   <a:srgbClr val="E8EEF9"/>
                 </a:solidFill>
               </a:rPr>
-              <a:t>Alice: біт + базис</a:t>
-            </a:r>
+              <a:t>Alice: </a:t>
+            </a:r>
+            <a:r>
+              <a:rPr sz="1600" dirty="0" err="1">
+                <a:solidFill>
+                  <a:srgbClr val="E8EEF9"/>
+                </a:solidFill>
+              </a:rPr>
+              <a:t>біт</a:t>
+            </a:r>
+            <a:r>
+              <a:rPr sz="1600" dirty="0">
+                <a:solidFill>
+                  <a:srgbClr val="E8EEF9"/>
+                </a:solidFill>
+              </a:rPr>
+              <a:t> + </a:t>
+            </a:r>
+            <a:r>
+              <a:rPr sz="1600" dirty="0" err="1">
+                <a:solidFill>
+                  <a:srgbClr val="E8EEF9"/>
+                </a:solidFill>
+              </a:rPr>
+              <a:t>базис</a:t>
+            </a:r>
+            <a:endParaRPr sz="1600" dirty="0">
+              <a:solidFill>
+                <a:srgbClr val="E8EEF9"/>
+              </a:solidFill>
+            </a:endParaRPr>
           </a:p>
         </p:txBody>
       </p:sp>
@@ -4325,7 +4375,7 @@
           <a:lstStyle/>
           <a:p>
             <a:pPr algn="ctr"/>
-            <a:endParaRPr/>
+            <a:endParaRPr sz="1600"/>
           </a:p>
         </p:txBody>
       </p:sp>
@@ -4372,7 +4422,7 @@
           <a:p>
             <a:pPr algn="ctr"/>
             <a:r>
-              <a:rPr sz="1400" b="1">
+              <a:rPr sz="1600" b="1">
                 <a:solidFill>
                   <a:srgbClr val="FFFFFF"/>
                 </a:solidFill>
@@ -4383,7 +4433,7 @@
           <a:p>
             <a:pPr algn="ctr"/>
             <a:r>
-              <a:rPr sz="1000">
+              <a:rPr sz="1600">
                 <a:solidFill>
                   <a:srgbClr val="E8EEF9"/>
                 </a:solidFill>
@@ -4433,7 +4483,7 @@
           <a:lstStyle/>
           <a:p>
             <a:pPr algn="ctr"/>
-            <a:endParaRPr/>
+            <a:endParaRPr sz="1600"/>
           </a:p>
         </p:txBody>
       </p:sp>
@@ -4480,7 +4530,7 @@
           <a:p>
             <a:pPr algn="ctr"/>
             <a:r>
-              <a:rPr sz="1400" b="1">
+              <a:rPr sz="1600" b="1">
                 <a:solidFill>
                   <a:srgbClr val="FFFFFF"/>
                 </a:solidFill>
@@ -4491,7 +4541,7 @@
           <a:p>
             <a:pPr algn="ctr"/>
             <a:r>
-              <a:rPr sz="1000">
+              <a:rPr sz="1600">
                 <a:solidFill>
                   <a:srgbClr val="E8EEF9"/>
                 </a:solidFill>
@@ -4541,7 +4591,7 @@
           <a:lstStyle/>
           <a:p>
             <a:pPr algn="ctr"/>
-            <a:endParaRPr/>
+            <a:endParaRPr sz="1600"/>
           </a:p>
         </p:txBody>
       </p:sp>
@@ -4588,7 +4638,7 @@
           <a:p>
             <a:pPr algn="ctr"/>
             <a:r>
-              <a:rPr sz="1400" b="1">
+              <a:rPr sz="1600" b="1">
                 <a:solidFill>
                   <a:srgbClr val="FFFFFF"/>
                 </a:solidFill>
@@ -4599,7 +4649,7 @@
           <a:p>
             <a:pPr algn="ctr"/>
             <a:r>
-              <a:rPr sz="1000">
+              <a:rPr sz="1600">
                 <a:solidFill>
                   <a:srgbClr val="E8EEF9"/>
                 </a:solidFill>
@@ -4649,7 +4699,7 @@
           <a:lstStyle/>
           <a:p>
             <a:pPr algn="ctr"/>
-            <a:endParaRPr/>
+            <a:endParaRPr sz="1600"/>
           </a:p>
         </p:txBody>
       </p:sp>
@@ -4696,7 +4746,7 @@
           <a:p>
             <a:pPr algn="ctr"/>
             <a:r>
-              <a:rPr sz="1400" b="1">
+              <a:rPr sz="1600" b="1">
                 <a:solidFill>
                   <a:srgbClr val="FFFFFF"/>
                 </a:solidFill>
@@ -4707,7 +4757,7 @@
           <a:p>
             <a:pPr algn="ctr"/>
             <a:r>
-              <a:rPr sz="1000">
+              <a:rPr sz="1600">
                 <a:solidFill>
                   <a:srgbClr val="E8EEF9"/>
                 </a:solidFill>
@@ -4757,7 +4807,7 @@
           <a:lstStyle/>
           <a:p>
             <a:pPr algn="ctr"/>
-            <a:endParaRPr/>
+            <a:endParaRPr sz="1600"/>
           </a:p>
         </p:txBody>
       </p:sp>
@@ -4804,7 +4854,7 @@
           <a:p>
             <a:pPr algn="ctr"/>
             <a:r>
-              <a:rPr sz="1400" b="1">
+              <a:rPr sz="1600" b="1">
                 <a:solidFill>
                   <a:srgbClr val="FFFFFF"/>
                 </a:solidFill>
@@ -4815,7 +4865,7 @@
           <a:p>
             <a:pPr algn="ctr"/>
             <a:r>
-              <a:rPr sz="1000">
+              <a:rPr sz="1600">
                 <a:solidFill>
                   <a:srgbClr val="E8EEF9"/>
                 </a:solidFill>
@@ -4834,7 +4884,7 @@
         <p:spPr>
           <a:xfrm>
             <a:off x="600000" y="3650000"/>
-            <a:ext cx="10992000" cy="600000"/>
+            <a:ext cx="10992000" cy="338554"/>
           </a:xfrm>
           <a:prstGeom prst="rect">
             <a:avLst/>
@@ -4849,7 +4899,7 @@
           <a:p>
             <a:pPr algn="ctr"/>
             <a:r>
-              <a:rPr sz="1300" i="1">
+              <a:rPr sz="1600" i="1">
                 <a:solidFill>
                   <a:srgbClr val="445577"/>
                 </a:solidFill>
@@ -4901,47 +4951,406 @@
           <a:lstStyle/>
           <a:p>
             <a:r>
-              <a:rPr sz="1300">
+              <a:rPr sz="1600" dirty="0">
                 <a:solidFill>
                   <a:srgbClr val="222233"/>
                 </a:solidFill>
               </a:rPr>
-              <a:t>•  Джерело: ослаблений лазер або SPDC, μ ≈ 0.1–0.5 фотона/імпульс</a:t>
-            </a:r>
-          </a:p>
-          <a:p>
-            <a:r>
-              <a:rPr sz="1300">
+              <a:t>•  </a:t>
+            </a:r>
+            <a:r>
+              <a:rPr sz="1600" dirty="0" err="1">
                 <a:solidFill>
                   <a:srgbClr val="222233"/>
                 </a:solidFill>
               </a:rPr>
-              <a:t>•  Канал: оптоволокно ≤ 400 км (загасання ~0.2 дБ/км) або супутник</a:t>
-            </a:r>
-          </a:p>
-          <a:p>
-            <a:r>
-              <a:rPr sz="1300">
+              <a:t>Джерело</a:t>
+            </a:r>
+            <a:r>
+              <a:rPr sz="1600" dirty="0">
                 <a:solidFill>
                   <a:srgbClr val="222233"/>
                 </a:solidFill>
               </a:rPr>
-              <a:t>•  Детектори: SPAD / SNSPD з dark-count rate ~10⁻⁶</a:t>
-            </a:r>
-          </a:p>
-          <a:p>
-            <a:r>
-              <a:rPr sz="1300">
+              <a:t>: </a:t>
+            </a:r>
+            <a:r>
+              <a:rPr sz="1600" dirty="0" err="1">
                 <a:solidFill>
                   <a:srgbClr val="222233"/>
                 </a:solidFill>
               </a:rPr>
-              <a:t>•  Сифтинг: Alice і Bob оголошують базиси → ~50% ключа зберігається</a:t>
-            </a:r>
-          </a:p>
-          <a:p>
-            <a:r>
-              <a:rPr sz="1300">
+              <a:t>ослаблений</a:t>
+            </a:r>
+            <a:r>
+              <a:rPr sz="1600" dirty="0">
+                <a:solidFill>
+                  <a:srgbClr val="222233"/>
+                </a:solidFill>
+              </a:rPr>
+              <a:t> </a:t>
+            </a:r>
+            <a:r>
+              <a:rPr sz="1600" dirty="0" err="1">
+                <a:solidFill>
+                  <a:srgbClr val="222233"/>
+                </a:solidFill>
+              </a:rPr>
+              <a:t>лазер</a:t>
+            </a:r>
+            <a:r>
+              <a:rPr sz="1600" dirty="0">
+                <a:solidFill>
+                  <a:srgbClr val="222233"/>
+                </a:solidFill>
+              </a:rPr>
+              <a:t> </a:t>
+            </a:r>
+            <a:r>
+              <a:rPr sz="1600" dirty="0" err="1">
+                <a:solidFill>
+                  <a:srgbClr val="222233"/>
+                </a:solidFill>
+              </a:rPr>
+              <a:t>або</a:t>
+            </a:r>
+            <a:r>
+              <a:rPr sz="1600" dirty="0">
+                <a:solidFill>
+                  <a:srgbClr val="222233"/>
+                </a:solidFill>
+              </a:rPr>
+              <a:t> SPDC, </a:t>
+            </a:r>
+            <a:r>
+              <a:rPr sz="1600" dirty="0" err="1">
+                <a:solidFill>
+                  <a:srgbClr val="222233"/>
+                </a:solidFill>
+              </a:rPr>
+              <a:t>μ</a:t>
+            </a:r>
+            <a:r>
+              <a:rPr sz="1600" dirty="0">
+                <a:solidFill>
+                  <a:srgbClr val="222233"/>
+                </a:solidFill>
+              </a:rPr>
+              <a:t> ≈ 0.1–0.5 </a:t>
+            </a:r>
+            <a:r>
+              <a:rPr sz="1600" dirty="0" err="1">
+                <a:solidFill>
+                  <a:srgbClr val="222233"/>
+                </a:solidFill>
+              </a:rPr>
+              <a:t>фотона</a:t>
+            </a:r>
+            <a:r>
+              <a:rPr sz="1600" dirty="0">
+                <a:solidFill>
+                  <a:srgbClr val="222233"/>
+                </a:solidFill>
+              </a:rPr>
+              <a:t>/</a:t>
+            </a:r>
+            <a:r>
+              <a:rPr sz="1600" dirty="0" err="1">
+                <a:solidFill>
+                  <a:srgbClr val="222233"/>
+                </a:solidFill>
+              </a:rPr>
+              <a:t>імпульс</a:t>
+            </a:r>
+            <a:endParaRPr sz="1600" dirty="0">
+              <a:solidFill>
+                <a:srgbClr val="222233"/>
+              </a:solidFill>
+            </a:endParaRPr>
+          </a:p>
+          <a:p>
+            <a:r>
+              <a:rPr sz="1600" dirty="0">
+                <a:solidFill>
+                  <a:srgbClr val="222233"/>
+                </a:solidFill>
+              </a:rPr>
+              <a:t>•  </a:t>
+            </a:r>
+            <a:r>
+              <a:rPr sz="1600" dirty="0" err="1">
+                <a:solidFill>
+                  <a:srgbClr val="222233"/>
+                </a:solidFill>
+              </a:rPr>
+              <a:t>Канал</a:t>
+            </a:r>
+            <a:r>
+              <a:rPr sz="1600" dirty="0">
+                <a:solidFill>
+                  <a:srgbClr val="222233"/>
+                </a:solidFill>
+              </a:rPr>
+              <a:t>: </a:t>
+            </a:r>
+            <a:r>
+              <a:rPr sz="1600" dirty="0" err="1">
+                <a:solidFill>
+                  <a:srgbClr val="222233"/>
+                </a:solidFill>
+              </a:rPr>
+              <a:t>оптоволокно</a:t>
+            </a:r>
+            <a:r>
+              <a:rPr sz="1600" dirty="0">
+                <a:solidFill>
+                  <a:srgbClr val="222233"/>
+                </a:solidFill>
+              </a:rPr>
+              <a:t> ≤ 400 </a:t>
+            </a:r>
+            <a:r>
+              <a:rPr sz="1600" dirty="0" err="1">
+                <a:solidFill>
+                  <a:srgbClr val="222233"/>
+                </a:solidFill>
+              </a:rPr>
+              <a:t>км</a:t>
+            </a:r>
+            <a:r>
+              <a:rPr sz="1600" dirty="0">
+                <a:solidFill>
+                  <a:srgbClr val="222233"/>
+                </a:solidFill>
+              </a:rPr>
+              <a:t> (</a:t>
+            </a:r>
+            <a:r>
+              <a:rPr sz="1600" dirty="0" err="1">
+                <a:solidFill>
+                  <a:srgbClr val="222233"/>
+                </a:solidFill>
+              </a:rPr>
+              <a:t>загасання</a:t>
+            </a:r>
+            <a:r>
+              <a:rPr sz="1600" dirty="0">
+                <a:solidFill>
+                  <a:srgbClr val="222233"/>
+                </a:solidFill>
+              </a:rPr>
+              <a:t> ~0.2 </a:t>
+            </a:r>
+            <a:r>
+              <a:rPr sz="1600" dirty="0" err="1">
+                <a:solidFill>
+                  <a:srgbClr val="222233"/>
+                </a:solidFill>
+              </a:rPr>
+              <a:t>дБ</a:t>
+            </a:r>
+            <a:r>
+              <a:rPr sz="1600" dirty="0">
+                <a:solidFill>
+                  <a:srgbClr val="222233"/>
+                </a:solidFill>
+              </a:rPr>
+              <a:t>/</a:t>
+            </a:r>
+            <a:r>
+              <a:rPr sz="1600" dirty="0" err="1">
+                <a:solidFill>
+                  <a:srgbClr val="222233"/>
+                </a:solidFill>
+              </a:rPr>
+              <a:t>км</a:t>
+            </a:r>
+            <a:r>
+              <a:rPr sz="1600" dirty="0">
+                <a:solidFill>
+                  <a:srgbClr val="222233"/>
+                </a:solidFill>
+              </a:rPr>
+              <a:t>) </a:t>
+            </a:r>
+            <a:r>
+              <a:rPr sz="1600" dirty="0" err="1">
+                <a:solidFill>
+                  <a:srgbClr val="222233"/>
+                </a:solidFill>
+              </a:rPr>
+              <a:t>або</a:t>
+            </a:r>
+            <a:r>
+              <a:rPr sz="1600" dirty="0">
+                <a:solidFill>
+                  <a:srgbClr val="222233"/>
+                </a:solidFill>
+              </a:rPr>
+              <a:t> </a:t>
+            </a:r>
+            <a:r>
+              <a:rPr sz="1600" dirty="0" err="1">
+                <a:solidFill>
+                  <a:srgbClr val="222233"/>
+                </a:solidFill>
+              </a:rPr>
+              <a:t>супутник</a:t>
+            </a:r>
+            <a:endParaRPr sz="1600" dirty="0">
+              <a:solidFill>
+                <a:srgbClr val="222233"/>
+              </a:solidFill>
+            </a:endParaRPr>
+          </a:p>
+          <a:p>
+            <a:r>
+              <a:rPr sz="1600" dirty="0">
+                <a:solidFill>
+                  <a:srgbClr val="222233"/>
+                </a:solidFill>
+              </a:rPr>
+              <a:t>•  </a:t>
+            </a:r>
+            <a:r>
+              <a:rPr sz="1600" dirty="0" err="1">
+                <a:solidFill>
+                  <a:srgbClr val="222233"/>
+                </a:solidFill>
+              </a:rPr>
+              <a:t>Детектори</a:t>
+            </a:r>
+            <a:r>
+              <a:rPr sz="1600" dirty="0">
+                <a:solidFill>
+                  <a:srgbClr val="222233"/>
+                </a:solidFill>
+              </a:rPr>
+              <a:t>: SPAD / SNSPD </a:t>
+            </a:r>
+            <a:r>
+              <a:rPr sz="1600" dirty="0" err="1">
+                <a:solidFill>
+                  <a:srgbClr val="222233"/>
+                </a:solidFill>
+              </a:rPr>
+              <a:t>з</a:t>
+            </a:r>
+            <a:r>
+              <a:rPr sz="1600" dirty="0">
+                <a:solidFill>
+                  <a:srgbClr val="222233"/>
+                </a:solidFill>
+              </a:rPr>
+              <a:t> dark-count rate ~10⁻⁶</a:t>
+            </a:r>
+          </a:p>
+          <a:p>
+            <a:r>
+              <a:rPr sz="1600" dirty="0">
+                <a:solidFill>
+                  <a:srgbClr val="222233"/>
+                </a:solidFill>
+              </a:rPr>
+              <a:t>•  </a:t>
+            </a:r>
+            <a:r>
+              <a:rPr sz="1600" dirty="0" err="1">
+                <a:solidFill>
+                  <a:srgbClr val="222233"/>
+                </a:solidFill>
+              </a:rPr>
+              <a:t>Сифтинг</a:t>
+            </a:r>
+            <a:r>
+              <a:rPr sz="1600" dirty="0">
+                <a:solidFill>
+                  <a:srgbClr val="222233"/>
+                </a:solidFill>
+              </a:rPr>
+              <a:t>: Alice </a:t>
+            </a:r>
+            <a:r>
+              <a:rPr sz="1600" dirty="0" err="1">
+                <a:solidFill>
+                  <a:srgbClr val="222233"/>
+                </a:solidFill>
+              </a:rPr>
+              <a:t>і</a:t>
+            </a:r>
+            <a:r>
+              <a:rPr sz="1600" dirty="0">
+                <a:solidFill>
+                  <a:srgbClr val="222233"/>
+                </a:solidFill>
+              </a:rPr>
+              <a:t> Bob </a:t>
+            </a:r>
+            <a:r>
+              <a:rPr sz="1600" dirty="0" err="1">
+                <a:solidFill>
+                  <a:srgbClr val="222233"/>
+                </a:solidFill>
+              </a:rPr>
+              <a:t>оголошують</a:t>
+            </a:r>
+            <a:r>
+              <a:rPr sz="1600" dirty="0">
+                <a:solidFill>
+                  <a:srgbClr val="222233"/>
+                </a:solidFill>
+              </a:rPr>
+              <a:t> </a:t>
+            </a:r>
+            <a:r>
+              <a:rPr sz="1600" dirty="0" err="1">
+                <a:solidFill>
+                  <a:srgbClr val="222233"/>
+                </a:solidFill>
+              </a:rPr>
+              <a:t>базиси</a:t>
+            </a:r>
+            <a:r>
+              <a:rPr sz="1600" dirty="0">
+                <a:solidFill>
+                  <a:srgbClr val="222233"/>
+                </a:solidFill>
+              </a:rPr>
+              <a:t> → ~50% </a:t>
+            </a:r>
+            <a:r>
+              <a:rPr sz="1600" dirty="0" err="1">
+                <a:solidFill>
+                  <a:srgbClr val="222233"/>
+                </a:solidFill>
+              </a:rPr>
+              <a:t>ключа</a:t>
+            </a:r>
+            <a:r>
+              <a:rPr sz="1600" dirty="0">
+                <a:solidFill>
+                  <a:srgbClr val="222233"/>
+                </a:solidFill>
+              </a:rPr>
+              <a:t> </a:t>
+            </a:r>
+            <a:r>
+              <a:rPr sz="1600" dirty="0" err="1">
+                <a:solidFill>
+                  <a:srgbClr val="222233"/>
+                </a:solidFill>
+              </a:rPr>
+              <a:t>зберігається</a:t>
+            </a:r>
+            <a:endParaRPr sz="1600" dirty="0">
+              <a:solidFill>
+                <a:srgbClr val="222233"/>
+              </a:solidFill>
+            </a:endParaRPr>
+          </a:p>
+          <a:p>
+            <a:r>
+              <a:rPr sz="1600" dirty="0">
                 <a:solidFill>
                   <a:srgbClr val="222233"/>
                 </a:solidFill>
@@ -5112,7 +5521,13 @@
           <p:cNvGraphicFramePr>
             <a:graphicFrameLocks noGrp="1"/>
           </p:cNvGraphicFramePr>
-          <p:nvPr/>
+          <p:nvPr>
+            <p:extLst>
+              <p:ext uri="{D42A27DB-BD31-4B8C-83A1-F6EECF244321}">
+                <p14:modId xmlns:p14="http://schemas.microsoft.com/office/powerpoint/2010/main" val="2984212145"/>
+              </p:ext>
+            </p:extLst>
+          </p:nvPr>
         </p:nvGraphicFramePr>
         <p:xfrm>
           <a:off x="500000" y="1750000"/>
@@ -5168,7 +5583,7 @@
                     <a:lstStyle/>
                     <a:p>
                       <a:r>
-                        <a:rPr sz="1300" b="1">
+                        <a:rPr sz="1400" b="1">
                           <a:solidFill>
                             <a:srgbClr val="FFFFFF"/>
                           </a:solidFill>
@@ -5189,7 +5604,7 @@
                     <a:lstStyle/>
                     <a:p>
                       <a:r>
-                        <a:rPr sz="1300" b="1">
+                        <a:rPr sz="1400" b="1">
                           <a:solidFill>
                             <a:srgbClr val="FFFFFF"/>
                           </a:solidFill>
@@ -5210,7 +5625,7 @@
                     <a:lstStyle/>
                     <a:p>
                       <a:r>
-                        <a:rPr sz="1300" b="1">
+                        <a:rPr sz="1400" b="1">
                           <a:solidFill>
                             <a:srgbClr val="FFFFFF"/>
                           </a:solidFill>
@@ -5231,7 +5646,7 @@
                     <a:lstStyle/>
                     <a:p>
                       <a:r>
-                        <a:rPr sz="1300" b="1">
+                        <a:rPr sz="1400" b="1">
                           <a:solidFill>
                             <a:srgbClr val="FFFFFF"/>
                           </a:solidFill>
@@ -5252,7 +5667,7 @@
                     <a:lstStyle/>
                     <a:p>
                       <a:r>
-                        <a:rPr sz="1300" b="1">
+                        <a:rPr sz="1400" b="1">
                           <a:solidFill>
                             <a:srgbClr val="FFFFFF"/>
                           </a:solidFill>
@@ -5280,7 +5695,7 @@
                     <a:lstStyle/>
                     <a:p>
                       <a:r>
-                        <a:rPr sz="1100">
+                        <a:rPr sz="1400">
                           <a:solidFill>
                             <a:srgbClr val="1F1F2E"/>
                           </a:solidFill>
@@ -5301,7 +5716,7 @@
                     <a:lstStyle/>
                     <a:p>
                       <a:r>
-                        <a:rPr sz="1100">
+                        <a:rPr sz="1400">
                           <a:solidFill>
                             <a:srgbClr val="1F1F2E"/>
                           </a:solidFill>
@@ -5322,7 +5737,7 @@
                     <a:lstStyle/>
                     <a:p>
                       <a:r>
-                        <a:rPr sz="1100">
+                        <a:rPr sz="1400">
                           <a:solidFill>
                             <a:srgbClr val="1F1F2E"/>
                           </a:solidFill>
@@ -5343,7 +5758,7 @@
                     <a:lstStyle/>
                     <a:p>
                       <a:r>
-                        <a:rPr sz="1100">
+                        <a:rPr sz="1400">
                           <a:solidFill>
                             <a:srgbClr val="1F1F2E"/>
                           </a:solidFill>
@@ -5364,7 +5779,7 @@
                     <a:lstStyle/>
                     <a:p>
                       <a:r>
-                        <a:rPr sz="1100">
+                        <a:rPr sz="1400">
                           <a:solidFill>
                             <a:srgbClr val="1F1F2E"/>
                           </a:solidFill>
@@ -5392,7 +5807,7 @@
                     <a:lstStyle/>
                     <a:p>
                       <a:r>
-                        <a:rPr sz="1100">
+                        <a:rPr sz="1400">
                           <a:solidFill>
                             <a:srgbClr val="1F1F2E"/>
                           </a:solidFill>
@@ -5413,7 +5828,7 @@
                     <a:lstStyle/>
                     <a:p>
                       <a:r>
-                        <a:rPr sz="1100">
+                        <a:rPr sz="1400">
                           <a:solidFill>
                             <a:srgbClr val="1F1F2E"/>
                           </a:solidFill>
@@ -5434,7 +5849,7 @@
                     <a:lstStyle/>
                     <a:p>
                       <a:r>
-                        <a:rPr sz="1100">
+                        <a:rPr sz="1400">
                           <a:solidFill>
                             <a:srgbClr val="1F1F2E"/>
                           </a:solidFill>
@@ -5455,7 +5870,7 @@
                     <a:lstStyle/>
                     <a:p>
                       <a:r>
-                        <a:rPr sz="1100">
+                        <a:rPr sz="1400">
                           <a:solidFill>
                             <a:srgbClr val="1F1F2E"/>
                           </a:solidFill>
@@ -5476,7 +5891,7 @@
                     <a:lstStyle/>
                     <a:p>
                       <a:r>
-                        <a:rPr sz="1100">
+                        <a:rPr sz="1400">
                           <a:solidFill>
                             <a:srgbClr val="1F1F2E"/>
                           </a:solidFill>
@@ -5504,7 +5919,7 @@
                     <a:lstStyle/>
                     <a:p>
                       <a:r>
-                        <a:rPr sz="1100">
+                        <a:rPr sz="1400">
                           <a:solidFill>
                             <a:srgbClr val="1F1F2E"/>
                           </a:solidFill>
@@ -5525,7 +5940,7 @@
                     <a:lstStyle/>
                     <a:p>
                       <a:r>
-                        <a:rPr sz="1100">
+                        <a:rPr sz="1400">
                           <a:solidFill>
                             <a:srgbClr val="1F1F2E"/>
                           </a:solidFill>
@@ -5546,7 +5961,7 @@
                     <a:lstStyle/>
                     <a:p>
                       <a:r>
-                        <a:rPr sz="1100">
+                        <a:rPr sz="1400">
                           <a:solidFill>
                             <a:srgbClr val="1F1F2E"/>
                           </a:solidFill>
@@ -5567,7 +5982,7 @@
                     <a:lstStyle/>
                     <a:p>
                       <a:r>
-                        <a:rPr sz="1100">
+                        <a:rPr sz="1400">
                           <a:solidFill>
                             <a:srgbClr val="1F1F2E"/>
                           </a:solidFill>
@@ -5588,7 +6003,7 @@
                     <a:lstStyle/>
                     <a:p>
                       <a:r>
-                        <a:rPr sz="1100">
+                        <a:rPr sz="1400">
                           <a:solidFill>
                             <a:srgbClr val="1F1F2E"/>
                           </a:solidFill>
@@ -5616,7 +6031,7 @@
                     <a:lstStyle/>
                     <a:p>
                       <a:r>
-                        <a:rPr sz="1100">
+                        <a:rPr sz="1400">
                           <a:solidFill>
                             <a:srgbClr val="1F1F2E"/>
                           </a:solidFill>
@@ -5637,12 +6052,28 @@
                     <a:lstStyle/>
                     <a:p>
                       <a:r>
-                        <a:rPr sz="1100">
+                        <a:rPr sz="1400" dirty="0">
                           <a:solidFill>
                             <a:srgbClr val="1F1F2E"/>
                           </a:solidFill>
                         </a:rPr>
-                        <a:t>× (X, діаг.)</a:t>
+                        <a:t>× (X, </a:t>
+                      </a:r>
+                      <a:r>
+                        <a:rPr sz="1400" dirty="0" err="1">
+                          <a:solidFill>
+                            <a:srgbClr val="1F1F2E"/>
+                          </a:solidFill>
+                        </a:rPr>
+                        <a:t>діаг</a:t>
+                      </a:r>
+                      <a:r>
+                        <a:rPr sz="1400" dirty="0">
+                          <a:solidFill>
+                            <a:srgbClr val="1F1F2E"/>
+                          </a:solidFill>
+                        </a:rPr>
+                        <a:t>.)</a:t>
                       </a:r>
                     </a:p>
                   </a:txBody>
@@ -5658,7 +6089,7 @@
                     <a:lstStyle/>
                     <a:p>
                       <a:r>
-                        <a:rPr sz="1100">
+                        <a:rPr sz="1400">
                           <a:solidFill>
                             <a:srgbClr val="1F1F2E"/>
                           </a:solidFill>
@@ -5679,7 +6110,7 @@
                     <a:lstStyle/>
                     <a:p>
                       <a:r>
-                        <a:rPr sz="1100">
+                        <a:rPr sz="1400">
                           <a:solidFill>
                             <a:srgbClr val="1F1F2E"/>
                           </a:solidFill>
@@ -5700,7 +6131,7 @@
                     <a:lstStyle/>
                     <a:p>
                       <a:r>
-                        <a:rPr sz="1100">
+                        <a:rPr sz="1400" dirty="0">
                           <a:solidFill>
                             <a:srgbClr val="1F1F2E"/>
                           </a:solidFill>
@@ -5734,7 +6165,7 @@
         <p:spPr>
           <a:xfrm>
             <a:off x="500000" y="5908000"/>
-            <a:ext cx="11192000" cy="400000"/>
+            <a:ext cx="11192000" cy="338554"/>
           </a:xfrm>
           <a:prstGeom prst="rect">
             <a:avLst/>
@@ -5748,7 +6179,7 @@
           <a:lstStyle/>
           <a:p>
             <a:r>
-              <a:rPr sz="1200" i="1">
+              <a:rPr sz="1600" i="1">
                 <a:solidFill>
                   <a:srgbClr val="555566"/>
                 </a:solidFill>
@@ -5956,12 +6387,20 @@
           <a:p>
             <a:pPr algn="ctr"/>
             <a:r>
-              <a:rPr sz="1800" b="1">
+              <a:rPr sz="1600" b="1" dirty="0" err="1">
                 <a:solidFill>
                   <a:srgbClr val="FFFFFF"/>
                 </a:solidFill>
               </a:rPr>
-              <a:t>Оцінка QBER</a:t>
+              <a:t>Оцінка</a:t>
+            </a:r>
+            <a:r>
+              <a:rPr sz="1600" b="1" dirty="0">
+                <a:solidFill>
+                  <a:srgbClr val="FFFFFF"/>
+                </a:solidFill>
+              </a:rPr>
+              <a:t> QBER</a:t>
             </a:r>
           </a:p>
         </p:txBody>
@@ -6008,53 +6447,236 @@
           <a:lstStyle/>
           <a:p>
             <a:r>
-              <a:rPr sz="1300">
+              <a:rPr sz="1600" dirty="0">
                 <a:solidFill>
                   <a:srgbClr val="222233"/>
                 </a:solidFill>
               </a:rPr>
-              <a:t>•  QBER = помилкові біти / тестова вибірка</a:t>
-            </a:r>
-          </a:p>
-          <a:p>
-            <a:r>
-              <a:rPr sz="1300">
+              <a:t>•  QBER = </a:t>
+            </a:r>
+            <a:r>
+              <a:rPr sz="1600" dirty="0" err="1">
                 <a:solidFill>
                   <a:srgbClr val="222233"/>
                 </a:solidFill>
               </a:rPr>
-              <a:t>•  Без Eve: QBER ≈ dark counts + optics ≈ 1–3%</a:t>
-            </a:r>
-          </a:p>
-          <a:p>
-            <a:r>
-              <a:rPr sz="1300">
+              <a:t>помилкові</a:t>
+            </a:r>
+            <a:r>
+              <a:rPr sz="1600" dirty="0">
                 <a:solidFill>
                   <a:srgbClr val="222233"/>
                 </a:solidFill>
               </a:rPr>
+              <a:t> </a:t>
+            </a:r>
+            <a:r>
+              <a:rPr sz="1600" dirty="0" err="1">
+                <a:solidFill>
+                  <a:srgbClr val="222233"/>
+                </a:solidFill>
+              </a:rPr>
+              <a:t>біти</a:t>
+            </a:r>
+            <a:r>
+              <a:rPr sz="1600" dirty="0">
+                <a:solidFill>
+                  <a:srgbClr val="222233"/>
+                </a:solidFill>
+              </a:rPr>
+              <a:t> / </a:t>
+            </a:r>
+            <a:r>
+              <a:rPr sz="1600" dirty="0" err="1">
+                <a:solidFill>
+                  <a:srgbClr val="222233"/>
+                </a:solidFill>
+              </a:rPr>
+              <a:t>тестова</a:t>
+            </a:r>
+            <a:r>
+              <a:rPr sz="1600" dirty="0">
+                <a:solidFill>
+                  <a:srgbClr val="222233"/>
+                </a:solidFill>
+              </a:rPr>
+              <a:t> </a:t>
+            </a:r>
+            <a:r>
+              <a:rPr sz="1600" dirty="0" err="1">
+                <a:solidFill>
+                  <a:srgbClr val="222233"/>
+                </a:solidFill>
+              </a:rPr>
+              <a:t>вибірка</a:t>
+            </a:r>
+            <a:endParaRPr sz="1600" dirty="0">
+              <a:solidFill>
+                <a:srgbClr val="222233"/>
+              </a:solidFill>
+            </a:endParaRPr>
+          </a:p>
+          <a:p>
+            <a:r>
+              <a:rPr sz="1600" dirty="0">
+                <a:solidFill>
+                  <a:srgbClr val="222233"/>
+                </a:solidFill>
+              </a:rPr>
+              <a:t>•  </a:t>
+            </a:r>
+            <a:r>
+              <a:rPr sz="1600" dirty="0" err="1">
+                <a:solidFill>
+                  <a:srgbClr val="222233"/>
+                </a:solidFill>
+              </a:rPr>
+              <a:t>Без</a:t>
+            </a:r>
+            <a:r>
+              <a:rPr sz="1600" dirty="0">
+                <a:solidFill>
+                  <a:srgbClr val="222233"/>
+                </a:solidFill>
+              </a:rPr>
+              <a:t> Eve: QBER ≈ dark counts + optics ≈ 1–3%</a:t>
+            </a:r>
+          </a:p>
+          <a:p>
+            <a:r>
+              <a:rPr sz="1600" dirty="0">
+                <a:solidFill>
+                  <a:srgbClr val="222233"/>
+                </a:solidFill>
+              </a:rPr>
               <a:t>•  Intercept-resend Eve: QBER = 25%</a:t>
             </a:r>
           </a:p>
           <a:p>
             <a:r>
-              <a:rPr sz="1300">
+              <a:rPr sz="1600" dirty="0">
                 <a:solidFill>
                   <a:srgbClr val="222233"/>
                 </a:solidFill>
               </a:rPr>
-              <a:t>•  Beam-splitter (PNS): QBER = 0%, але знижена швидкість</a:t>
-            </a:r>
-          </a:p>
-          <a:p>
-            <a:r>
-              <a:rPr sz="1300">
+              <a:t>•  Beam-splitter (PNS): QBER = 0%, </a:t>
+            </a:r>
+            <a:r>
+              <a:rPr sz="1600" dirty="0" err="1">
                 <a:solidFill>
                   <a:srgbClr val="222233"/>
                 </a:solidFill>
               </a:rPr>
-              <a:t>•  Тестова вибірка: розкриваються ~50% сифтованих</a:t>
-            </a:r>
+              <a:t>але</a:t>
+            </a:r>
+            <a:r>
+              <a:rPr sz="1600" dirty="0">
+                <a:solidFill>
+                  <a:srgbClr val="222233"/>
+                </a:solidFill>
+              </a:rPr>
+              <a:t> </a:t>
+            </a:r>
+            <a:r>
+              <a:rPr sz="1600" dirty="0" err="1">
+                <a:solidFill>
+                  <a:srgbClr val="222233"/>
+                </a:solidFill>
+              </a:rPr>
+              <a:t>знижена</a:t>
+            </a:r>
+            <a:r>
+              <a:rPr sz="1600" dirty="0">
+                <a:solidFill>
+                  <a:srgbClr val="222233"/>
+                </a:solidFill>
+              </a:rPr>
+              <a:t> </a:t>
+            </a:r>
+            <a:r>
+              <a:rPr sz="1600" dirty="0" err="1">
+                <a:solidFill>
+                  <a:srgbClr val="222233"/>
+                </a:solidFill>
+              </a:rPr>
+              <a:t>швидкість</a:t>
+            </a:r>
+            <a:endParaRPr sz="1600" dirty="0">
+              <a:solidFill>
+                <a:srgbClr val="222233"/>
+              </a:solidFill>
+            </a:endParaRPr>
+          </a:p>
+          <a:p>
+            <a:r>
+              <a:rPr sz="1600" dirty="0">
+                <a:solidFill>
+                  <a:srgbClr val="222233"/>
+                </a:solidFill>
+              </a:rPr>
+              <a:t>•  </a:t>
+            </a:r>
+            <a:r>
+              <a:rPr sz="1600" dirty="0" err="1">
+                <a:solidFill>
+                  <a:srgbClr val="222233"/>
+                </a:solidFill>
+              </a:rPr>
+              <a:t>Тестова</a:t>
+            </a:r>
+            <a:r>
+              <a:rPr sz="1600" dirty="0">
+                <a:solidFill>
+                  <a:srgbClr val="222233"/>
+                </a:solidFill>
+              </a:rPr>
+              <a:t> </a:t>
+            </a:r>
+            <a:r>
+              <a:rPr sz="1600" dirty="0" err="1">
+                <a:solidFill>
+                  <a:srgbClr val="222233"/>
+                </a:solidFill>
+              </a:rPr>
+              <a:t>вибірка</a:t>
+            </a:r>
+            <a:r>
+              <a:rPr sz="1600" dirty="0">
+                <a:solidFill>
+                  <a:srgbClr val="222233"/>
+                </a:solidFill>
+              </a:rPr>
+              <a:t>: </a:t>
+            </a:r>
+            <a:r>
+              <a:rPr sz="1600" dirty="0" err="1">
+                <a:solidFill>
+                  <a:srgbClr val="222233"/>
+                </a:solidFill>
+              </a:rPr>
+              <a:t>розкриваються</a:t>
+            </a:r>
+            <a:r>
+              <a:rPr sz="1600" dirty="0">
+                <a:solidFill>
+                  <a:srgbClr val="222233"/>
+                </a:solidFill>
+              </a:rPr>
+              <a:t> ~50% </a:t>
+            </a:r>
+            <a:r>
+              <a:rPr sz="1600" dirty="0" err="1">
+                <a:solidFill>
+                  <a:srgbClr val="222233"/>
+                </a:solidFill>
+              </a:rPr>
+              <a:t>сифтованих</a:t>
+            </a:r>
+            <a:endParaRPr sz="1600" dirty="0">
+              <a:solidFill>
+                <a:srgbClr val="222233"/>
+              </a:solidFill>
+            </a:endParaRPr>
           </a:p>
         </p:txBody>
       </p:sp>
@@ -6101,7 +6723,7 @@
           <a:p>
             <a:pPr algn="ctr"/>
             <a:r>
-              <a:rPr sz="1800" b="1">
+              <a:rPr sz="1600" b="1">
                 <a:solidFill>
                   <a:srgbClr val="FFFFFF"/>
                 </a:solidFill>
@@ -6153,7 +6775,7 @@
           <a:lstStyle/>
           <a:p>
             <a:r>
-              <a:rPr sz="1300">
+              <a:rPr sz="1600">
                 <a:solidFill>
                   <a:srgbClr val="222233"/>
                 </a:solidFill>
@@ -6163,7 +6785,7 @@
           </a:p>
           <a:p>
             <a:r>
-              <a:rPr sz="1300">
+              <a:rPr sz="1600">
                 <a:solidFill>
                   <a:srgbClr val="222233"/>
                 </a:solidFill>
@@ -6173,7 +6795,7 @@
           </a:p>
           <a:p>
             <a:r>
-              <a:rPr sz="1300">
+              <a:rPr sz="1600">
                 <a:solidFill>
                   <a:srgbClr val="222233"/>
                 </a:solidFill>
@@ -6183,7 +6805,7 @@
           </a:p>
           <a:p>
             <a:r>
-              <a:rPr sz="1300">
+              <a:rPr sz="1600">
                 <a:solidFill>
                   <a:srgbClr val="222233"/>
                 </a:solidFill>
@@ -6193,7 +6815,7 @@
           </a:p>
           <a:p>
             <a:r>
-              <a:rPr sz="1300">
+              <a:rPr sz="1600">
                 <a:solidFill>
                   <a:srgbClr val="222233"/>
                 </a:solidFill>
@@ -6212,7 +6834,7 @@
         <p:spPr>
           <a:xfrm>
             <a:off x="700000" y="6230000"/>
-            <a:ext cx="10792000" cy="500000"/>
+            <a:ext cx="10792000" cy="338554"/>
           </a:xfrm>
           <a:prstGeom prst="rect">
             <a:avLst/>
@@ -6227,7 +6849,7 @@
           <a:p>
             <a:pPr algn="ctr"/>
             <a:r>
-              <a:rPr sz="1400" b="1">
+              <a:rPr sz="1600" b="1">
                 <a:solidFill>
                   <a:srgbClr val="445577"/>
                 </a:solidFill>
@@ -6398,7 +7020,13 @@
           <p:cNvGraphicFramePr>
             <a:graphicFrameLocks noGrp="1"/>
           </p:cNvGraphicFramePr>
-          <p:nvPr/>
+          <p:nvPr>
+            <p:extLst>
+              <p:ext uri="{D42A27DB-BD31-4B8C-83A1-F6EECF244321}">
+                <p14:modId xmlns:p14="http://schemas.microsoft.com/office/powerpoint/2010/main" val="363941814"/>
+              </p:ext>
+            </p:extLst>
+          </p:nvPr>
         </p:nvGraphicFramePr>
         <p:xfrm>
           <a:off x="500000" y="1750000"/>
@@ -6454,7 +7082,7 @@
                     <a:lstStyle/>
                     <a:p>
                       <a:r>
-                        <a:rPr sz="1300" b="1">
+                        <a:rPr sz="1400" b="1">
                           <a:solidFill>
                             <a:srgbClr val="FFFFFF"/>
                           </a:solidFill>
@@ -6475,7 +7103,7 @@
                     <a:lstStyle/>
                     <a:p>
                       <a:r>
-                        <a:rPr sz="1300" b="1">
+                        <a:rPr sz="1400" b="1">
                           <a:solidFill>
                             <a:srgbClr val="FFFFFF"/>
                           </a:solidFill>
@@ -6496,7 +7124,7 @@
                     <a:lstStyle/>
                     <a:p>
                       <a:r>
-                        <a:rPr sz="1300" b="1">
+                        <a:rPr sz="1400" b="1">
                           <a:solidFill>
                             <a:srgbClr val="FFFFFF"/>
                           </a:solidFill>
@@ -6517,7 +7145,7 @@
                     <a:lstStyle/>
                     <a:p>
                       <a:r>
-                        <a:rPr sz="1300" b="1">
+                        <a:rPr sz="1400" b="1">
                           <a:solidFill>
                             <a:srgbClr val="FFFFFF"/>
                           </a:solidFill>
@@ -6538,7 +7166,7 @@
                     <a:lstStyle/>
                     <a:p>
                       <a:r>
-                        <a:rPr sz="1300" b="1">
+                        <a:rPr sz="1400" b="1">
                           <a:solidFill>
                             <a:srgbClr val="FFFFFF"/>
                           </a:solidFill>
@@ -6566,7 +7194,7 @@
                     <a:lstStyle/>
                     <a:p>
                       <a:r>
-                        <a:rPr sz="1100">
+                        <a:rPr sz="1400">
                           <a:solidFill>
                             <a:srgbClr val="1F1F2E"/>
                           </a:solidFill>
@@ -6587,7 +7215,7 @@
                     <a:lstStyle/>
                     <a:p>
                       <a:r>
-                        <a:rPr sz="1100">
+                        <a:rPr sz="1400">
                           <a:solidFill>
                             <a:srgbClr val="1F1F2E"/>
                           </a:solidFill>
@@ -6608,7 +7236,7 @@
                     <a:lstStyle/>
                     <a:p>
                       <a:r>
-                        <a:rPr sz="1100">
+                        <a:rPr sz="1400">
                           <a:solidFill>
                             <a:srgbClr val="1F1F2E"/>
                           </a:solidFill>
@@ -6629,7 +7257,7 @@
                     <a:lstStyle/>
                     <a:p>
                       <a:r>
-                        <a:rPr sz="1100">
+                        <a:rPr sz="1400">
                           <a:solidFill>
                             <a:srgbClr val="1F1F2E"/>
                           </a:solidFill>
@@ -6650,7 +7278,7 @@
                     <a:lstStyle/>
                     <a:p>
                       <a:r>
-                        <a:rPr sz="1100">
+                        <a:rPr sz="1400">
                           <a:solidFill>
                             <a:srgbClr val="1F1F2E"/>
                           </a:solidFill>
@@ -6678,7 +7306,7 @@
                     <a:lstStyle/>
                     <a:p>
                       <a:r>
-                        <a:rPr sz="1100">
+                        <a:rPr sz="1400">
                           <a:solidFill>
                             <a:srgbClr val="1F1F2E"/>
                           </a:solidFill>
@@ -6699,7 +7327,7 @@
                     <a:lstStyle/>
                     <a:p>
                       <a:r>
-                        <a:rPr sz="1100">
+                        <a:rPr sz="1400">
                           <a:solidFill>
                             <a:srgbClr val="1F1F2E"/>
                           </a:solidFill>
@@ -6720,13 +7348,42 @@
                     <a:lstStyle/>
                     <a:p>
                       <a:r>
-                        <a:rPr sz="1100">
+                        <a:rPr sz="1400" dirty="0">
                           <a:solidFill>
                             <a:srgbClr val="1F1F2E"/>
                           </a:solidFill>
                         </a:rPr>
-                        <a:t>2 неортогон. стани</a:t>
+                        <a:t>2 </a:t>
                       </a:r>
+                      <a:r>
+                        <a:rPr sz="1400" dirty="0" err="1">
+                          <a:solidFill>
+                            <a:srgbClr val="1F1F2E"/>
+                          </a:solidFill>
+                        </a:rPr>
+                        <a:t>неортогон</a:t>
+                      </a:r>
+                      <a:r>
+                        <a:rPr sz="1400" dirty="0">
+                          <a:solidFill>
+                            <a:srgbClr val="1F1F2E"/>
+                          </a:solidFill>
+                        </a:rPr>
+                        <a:t>. </a:t>
+                      </a:r>
+                      <a:r>
+                        <a:rPr sz="1400" dirty="0" err="1">
+                          <a:solidFill>
+                            <a:srgbClr val="1F1F2E"/>
+                          </a:solidFill>
+                        </a:rPr>
+                        <a:t>стани</a:t>
+                      </a:r>
+                      <a:endParaRPr sz="1400" dirty="0">
+                        <a:solidFill>
+                          <a:srgbClr val="1F1F2E"/>
+                        </a:solidFill>
+                      </a:endParaRPr>
                     </a:p>
                   </a:txBody>
                   <a:tcPr>
@@ -6741,7 +7398,7 @@
                     <a:lstStyle/>
                     <a:p>
                       <a:r>
-                        <a:rPr sz="1100">
+                        <a:rPr sz="1400">
                           <a:solidFill>
                             <a:srgbClr val="1F1F2E"/>
                           </a:solidFill>
@@ -6762,7 +7419,7 @@
                     <a:lstStyle/>
                     <a:p>
                       <a:r>
-                        <a:rPr sz="1100">
+                        <a:rPr sz="1400">
                           <a:solidFill>
                             <a:srgbClr val="1F1F2E"/>
                           </a:solidFill>
@@ -6790,7 +7447,7 @@
                     <a:lstStyle/>
                     <a:p>
                       <a:r>
-                        <a:rPr sz="1100">
+                        <a:rPr sz="1400">
                           <a:solidFill>
                             <a:srgbClr val="1F1F2E"/>
                           </a:solidFill>
@@ -6811,7 +7468,7 @@
                     <a:lstStyle/>
                     <a:p>
                       <a:r>
-                        <a:rPr sz="1100">
+                        <a:rPr sz="1400">
                           <a:solidFill>
                             <a:srgbClr val="1F1F2E"/>
                           </a:solidFill>
@@ -6832,7 +7489,7 @@
                     <a:lstStyle/>
                     <a:p>
                       <a:r>
-                        <a:rPr sz="1100">
+                        <a:rPr sz="1400">
                           <a:solidFill>
                             <a:srgbClr val="1F1F2E"/>
                           </a:solidFill>
@@ -6853,7 +7510,7 @@
                     <a:lstStyle/>
                     <a:p>
                       <a:r>
-                        <a:rPr sz="1100">
+                        <a:rPr sz="1400">
                           <a:solidFill>
                             <a:srgbClr val="1F1F2E"/>
                           </a:solidFill>
@@ -6874,7 +7531,7 @@
                     <a:lstStyle/>
                     <a:p>
                       <a:r>
-                        <a:rPr sz="1100">
+                        <a:rPr sz="1400">
                           <a:solidFill>
                             <a:srgbClr val="1F1F2E"/>
                           </a:solidFill>
@@ -6902,7 +7559,7 @@
                     <a:lstStyle/>
                     <a:p>
                       <a:r>
-                        <a:rPr sz="1100">
+                        <a:rPr sz="1400">
                           <a:solidFill>
                             <a:srgbClr val="1F1F2E"/>
                           </a:solidFill>
@@ -6923,7 +7580,7 @@
                     <a:lstStyle/>
                     <a:p>
                       <a:r>
-                        <a:rPr sz="1100">
+                        <a:rPr sz="1400">
                           <a:solidFill>
                             <a:srgbClr val="1F1F2E"/>
                           </a:solidFill>
@@ -6944,7 +7601,7 @@
                     <a:lstStyle/>
                     <a:p>
                       <a:r>
-                        <a:rPr sz="1100">
+                        <a:rPr sz="1400">
                           <a:solidFill>
                             <a:srgbClr val="1F1F2E"/>
                           </a:solidFill>
@@ -6965,7 +7622,7 @@
                     <a:lstStyle/>
                     <a:p>
                       <a:r>
-                        <a:rPr sz="1100">
+                        <a:rPr sz="1400">
                           <a:solidFill>
                             <a:srgbClr val="1F1F2E"/>
                           </a:solidFill>
@@ -6986,7 +7643,7 @@
                     <a:lstStyle/>
                     <a:p>
                       <a:r>
-                        <a:rPr sz="1100">
+                        <a:rPr sz="1400">
                           <a:solidFill>
                             <a:srgbClr val="1F1F2E"/>
                           </a:solidFill>
@@ -7014,7 +7671,7 @@
                     <a:lstStyle/>
                     <a:p>
                       <a:r>
-                        <a:rPr sz="1100">
+                        <a:rPr sz="1400">
                           <a:solidFill>
                             <a:srgbClr val="1F1F2E"/>
                           </a:solidFill>
@@ -7035,7 +7692,7 @@
                     <a:lstStyle/>
                     <a:p>
                       <a:r>
-                        <a:rPr sz="1100">
+                        <a:rPr sz="1400">
                           <a:solidFill>
                             <a:srgbClr val="1F1F2E"/>
                           </a:solidFill>
@@ -7056,7 +7713,7 @@
                     <a:lstStyle/>
                     <a:p>
                       <a:r>
-                        <a:rPr sz="1100">
+                        <a:rPr sz="1400">
                           <a:solidFill>
                             <a:srgbClr val="1F1F2E"/>
                           </a:solidFill>
@@ -7077,7 +7734,7 @@
                     <a:lstStyle/>
                     <a:p>
                       <a:r>
-                        <a:rPr sz="1100">
+                        <a:rPr sz="1400">
                           <a:solidFill>
                             <a:srgbClr val="1F1F2E"/>
                           </a:solidFill>
@@ -7098,7 +7755,7 @@
                     <a:lstStyle/>
                     <a:p>
                       <a:r>
-                        <a:rPr sz="1100">
+                        <a:rPr sz="1400">
                           <a:solidFill>
                             <a:srgbClr val="1F1F2E"/>
                           </a:solidFill>
@@ -7126,7 +7783,7 @@
                     <a:lstStyle/>
                     <a:p>
                       <a:r>
-                        <a:rPr sz="1100">
+                        <a:rPr sz="1400">
                           <a:solidFill>
                             <a:srgbClr val="1F1F2E"/>
                           </a:solidFill>
@@ -7147,7 +7804,7 @@
                     <a:lstStyle/>
                     <a:p>
                       <a:r>
-                        <a:rPr sz="1100">
+                        <a:rPr sz="1400">
                           <a:solidFill>
                             <a:srgbClr val="1F1F2E"/>
                           </a:solidFill>
@@ -7168,7 +7825,7 @@
                     <a:lstStyle/>
                     <a:p>
                       <a:r>
-                        <a:rPr sz="1100">
+                        <a:rPr sz="1400">
                           <a:solidFill>
                             <a:srgbClr val="1F1F2E"/>
                           </a:solidFill>
@@ -7189,7 +7846,7 @@
                     <a:lstStyle/>
                     <a:p>
                       <a:r>
-                        <a:rPr sz="1100">
+                        <a:rPr sz="1400">
                           <a:solidFill>
                             <a:srgbClr val="1F1F2E"/>
                           </a:solidFill>
@@ -7210,7 +7867,7 @@
                     <a:lstStyle/>
                     <a:p>
                       <a:r>
-                        <a:rPr sz="1100">
+                        <a:rPr sz="1400">
                           <a:solidFill>
                             <a:srgbClr val="1F1F2E"/>
                           </a:solidFill>
@@ -7238,7 +7895,7 @@
                     <a:lstStyle/>
                     <a:p>
                       <a:r>
-                        <a:rPr sz="1100">
+                        <a:rPr sz="1400">
                           <a:solidFill>
                             <a:srgbClr val="1F1F2E"/>
                           </a:solidFill>
@@ -7259,7 +7916,7 @@
                     <a:lstStyle/>
                     <a:p>
                       <a:r>
-                        <a:rPr sz="1100">
+                        <a:rPr sz="1400">
                           <a:solidFill>
                             <a:srgbClr val="1F1F2E"/>
                           </a:solidFill>
@@ -7280,7 +7937,7 @@
                     <a:lstStyle/>
                     <a:p>
                       <a:r>
-                        <a:rPr sz="1100">
+                        <a:rPr sz="1400">
                           <a:solidFill>
                             <a:srgbClr val="1F1F2E"/>
                           </a:solidFill>
@@ -7301,7 +7958,7 @@
                     <a:lstStyle/>
                     <a:p>
                       <a:r>
-                        <a:rPr sz="1100">
+                        <a:rPr sz="1400">
                           <a:solidFill>
                             <a:srgbClr val="1F1F2E"/>
                           </a:solidFill>
@@ -7322,7 +7979,7 @@
                     <a:lstStyle/>
                     <a:p>
                       <a:r>
-                        <a:rPr sz="1100">
+                        <a:rPr sz="1400">
                           <a:solidFill>
                             <a:srgbClr val="1F1F2E"/>
                           </a:solidFill>
@@ -7350,7 +8007,7 @@
                     <a:lstStyle/>
                     <a:p>
                       <a:r>
-                        <a:rPr sz="1100">
+                        <a:rPr sz="1400" dirty="0">
                           <a:solidFill>
                             <a:srgbClr val="1F1F2E"/>
                           </a:solidFill>
@@ -7371,7 +8028,7 @@
                     <a:lstStyle/>
                     <a:p>
                       <a:r>
-                        <a:rPr sz="1100">
+                        <a:rPr sz="1400">
                           <a:solidFill>
                             <a:srgbClr val="1F1F2E"/>
                           </a:solidFill>
@@ -7392,7 +8049,7 @@
                     <a:lstStyle/>
                     <a:p>
                       <a:r>
-                        <a:rPr sz="1100">
+                        <a:rPr sz="1400">
                           <a:solidFill>
                             <a:srgbClr val="1F1F2E"/>
                           </a:solidFill>
@@ -7413,7 +8070,7 @@
                     <a:lstStyle/>
                     <a:p>
                       <a:r>
-                        <a:rPr sz="1100">
+                        <a:rPr sz="1400">
                           <a:solidFill>
                             <a:srgbClr val="1F1F2E"/>
                           </a:solidFill>
@@ -7434,13 +8091,34 @@
                     <a:lstStyle/>
                     <a:p>
                       <a:r>
-                        <a:rPr sz="1100">
+                        <a:rPr sz="1400" dirty="0" err="1">
                           <a:solidFill>
                             <a:srgbClr val="1F1F2E"/>
                           </a:solidFill>
                         </a:rPr>
-                        <a:t>Дальність &gt; 500 км</a:t>
+                        <a:t>Дальність</a:t>
                       </a:r>
+                      <a:r>
+                        <a:rPr sz="1400" dirty="0">
+                          <a:solidFill>
+                            <a:srgbClr val="1F1F2E"/>
+                          </a:solidFill>
+                        </a:rPr>
+                        <a:t> &gt; 500 </a:t>
+                      </a:r>
+                      <a:r>
+                        <a:rPr sz="1400" dirty="0" err="1">
+                          <a:solidFill>
+                            <a:srgbClr val="1F1F2E"/>
+                          </a:solidFill>
+                        </a:rPr>
+                        <a:t>км</a:t>
+                      </a:r>
+                      <a:endParaRPr sz="1400" dirty="0">
+                        <a:solidFill>
+                          <a:srgbClr val="1F1F2E"/>
+                        </a:solidFill>
+                      </a:endParaRPr>
                     </a:p>
                   </a:txBody>
                   <a:tcPr>
@@ -7468,7 +8146,7 @@
         <p:spPr>
           <a:xfrm>
             <a:off x="500000" y="5908000"/>
-            <a:ext cx="11192000" cy="400000"/>
+            <a:ext cx="11192000" cy="307777"/>
           </a:xfrm>
           <a:prstGeom prst="rect">
             <a:avLst/>
@@ -7482,12 +8160,44 @@
           <a:lstStyle/>
           <a:p>
             <a:r>
-              <a:rPr sz="1200" i="1">
+              <a:rPr sz="1400" i="1" dirty="0">
                 <a:solidFill>
                   <a:srgbClr val="555566"/>
                 </a:solidFill>
               </a:rPr>
-              <a:t>BB84 + decoy states — домінуючий стандарт ITU-T Y.3800, ETSI QKD</a:t>
+              <a:t>BB84 + decoy states — </a:t>
+            </a:r>
+            <a:r>
+              <a:rPr sz="1400" i="1" dirty="0" err="1">
+                <a:solidFill>
+                  <a:srgbClr val="555566"/>
+                </a:solidFill>
+              </a:rPr>
+              <a:t>домінуючий</a:t>
+            </a:r>
+            <a:r>
+              <a:rPr sz="1400" i="1" dirty="0">
+                <a:solidFill>
+                  <a:srgbClr val="555566"/>
+                </a:solidFill>
+              </a:rPr>
+              <a:t> </a:t>
+            </a:r>
+            <a:r>
+              <a:rPr sz="1400" i="1" dirty="0" err="1">
+                <a:solidFill>
+                  <a:srgbClr val="555566"/>
+                </a:solidFill>
+              </a:rPr>
+              <a:t>стандарт</a:t>
+            </a:r>
+            <a:r>
+              <a:rPr sz="1400" i="1" dirty="0">
+                <a:solidFill>
+                  <a:srgbClr val="555566"/>
+                </a:solidFill>
+              </a:rPr>
+              <a:t> ITU-T Y.3800, ETSI QKD</a:t>
             </a:r>
           </a:p>
         </p:txBody>
@@ -7653,11 +8363,17 @@
           <p:cNvGraphicFramePr>
             <a:graphicFrameLocks noGrp="1"/>
           </p:cNvGraphicFramePr>
-          <p:nvPr/>
+          <p:nvPr>
+            <p:extLst>
+              <p:ext uri="{D42A27DB-BD31-4B8C-83A1-F6EECF244321}">
+                <p14:modId xmlns:p14="http://schemas.microsoft.com/office/powerpoint/2010/main" val="1445102492"/>
+              </p:ext>
+            </p:extLst>
+          </p:nvPr>
         </p:nvGraphicFramePr>
         <p:xfrm>
           <a:off x="500000" y="1750000"/>
-          <a:ext cx="11191999" cy="4058000"/>
+          <a:ext cx="11191999" cy="4079820"/>
         </p:xfrm>
         <a:graphic>
           <a:graphicData uri="http://schemas.openxmlformats.org/drawingml/2006/table">
@@ -7702,13 +8418,18 @@
                     <a:lstStyle/>
                     <a:p>
                       <a:r>
-                        <a:rPr sz="1300" b="1">
+                        <a:rPr sz="1600" b="1" dirty="0" err="1">
                           <a:solidFill>
                             <a:srgbClr val="FFFFFF"/>
                           </a:solidFill>
                         </a:rPr>
                         <a:t>Атака</a:t>
                       </a:r>
+                      <a:endParaRPr sz="1600" b="1" dirty="0">
+                        <a:solidFill>
+                          <a:srgbClr val="FFFFFF"/>
+                        </a:solidFill>
+                      </a:endParaRPr>
                     </a:p>
                   </a:txBody>
                   <a:tcPr>
@@ -7723,7 +8444,7 @@
                     <a:lstStyle/>
                     <a:p>
                       <a:r>
-                        <a:rPr sz="1300" b="1">
+                        <a:rPr sz="1600" b="1">
                           <a:solidFill>
                             <a:srgbClr val="FFFFFF"/>
                           </a:solidFill>
@@ -7744,7 +8465,7 @@
                     <a:lstStyle/>
                     <a:p>
                       <a:r>
-                        <a:rPr sz="1300" b="1">
+                        <a:rPr sz="1600" b="1">
                           <a:solidFill>
                             <a:srgbClr val="FFFFFF"/>
                           </a:solidFill>
@@ -7765,7 +8486,7 @@
                     <a:lstStyle/>
                     <a:p>
                       <a:r>
-                        <a:rPr sz="1300" b="1">
+                        <a:rPr sz="1600" b="1">
                           <a:solidFill>
                             <a:srgbClr val="FFFFFF"/>
                           </a:solidFill>
@@ -7793,7 +8514,7 @@
                     <a:lstStyle/>
                     <a:p>
                       <a:r>
-                        <a:rPr sz="1100">
+                        <a:rPr sz="1400">
                           <a:solidFill>
                             <a:srgbClr val="1F1F2E"/>
                           </a:solidFill>
@@ -7814,7 +8535,7 @@
                     <a:lstStyle/>
                     <a:p>
                       <a:r>
-                        <a:rPr sz="1100">
+                        <a:rPr sz="1400">
                           <a:solidFill>
                             <a:srgbClr val="1F1F2E"/>
                           </a:solidFill>
@@ -7835,7 +8556,7 @@
                     <a:lstStyle/>
                     <a:p>
                       <a:r>
-                        <a:rPr sz="1100">
+                        <a:rPr sz="1400">
                           <a:solidFill>
                             <a:srgbClr val="1F1F2E"/>
                           </a:solidFill>
@@ -7856,7 +8577,7 @@
                     <a:lstStyle/>
                     <a:p>
                       <a:r>
-                        <a:rPr sz="1100">
+                        <a:rPr sz="1400">
                           <a:solidFill>
                             <a:srgbClr val="1F1F2E"/>
                           </a:solidFill>
@@ -7884,7 +8605,7 @@
                     <a:lstStyle/>
                     <a:p>
                       <a:r>
-                        <a:rPr sz="1100">
+                        <a:rPr sz="1400">
                           <a:solidFill>
                             <a:srgbClr val="1F1F2E"/>
                           </a:solidFill>
@@ -7905,7 +8626,7 @@
                     <a:lstStyle/>
                     <a:p>
                       <a:r>
-                        <a:rPr sz="1100">
+                        <a:rPr sz="1400">
                           <a:solidFill>
                             <a:srgbClr val="1F1F2E"/>
                           </a:solidFill>
@@ -7926,7 +8647,7 @@
                     <a:lstStyle/>
                     <a:p>
                       <a:r>
-                        <a:rPr sz="1100">
+                        <a:rPr sz="1400">
                           <a:solidFill>
                             <a:srgbClr val="1F1F2E"/>
                           </a:solidFill>
@@ -7947,7 +8668,7 @@
                     <a:lstStyle/>
                     <a:p>
                       <a:r>
-                        <a:rPr sz="1100">
+                        <a:rPr sz="1400">
                           <a:solidFill>
                             <a:srgbClr val="1F1F2E"/>
                           </a:solidFill>
@@ -7975,7 +8696,7 @@
                     <a:lstStyle/>
                     <a:p>
                       <a:r>
-                        <a:rPr sz="1100">
+                        <a:rPr sz="1400">
                           <a:solidFill>
                             <a:srgbClr val="1F1F2E"/>
                           </a:solidFill>
@@ -7996,7 +8717,7 @@
                     <a:lstStyle/>
                     <a:p>
                       <a:r>
-                        <a:rPr sz="1100">
+                        <a:rPr sz="1400">
                           <a:solidFill>
                             <a:srgbClr val="1F1F2E"/>
                           </a:solidFill>
@@ -8017,7 +8738,7 @@
                     <a:lstStyle/>
                     <a:p>
                       <a:r>
-                        <a:rPr sz="1100">
+                        <a:rPr sz="1400">
                           <a:solidFill>
                             <a:srgbClr val="1F1F2E"/>
                           </a:solidFill>
@@ -8038,7 +8759,7 @@
                     <a:lstStyle/>
                     <a:p>
                       <a:r>
-                        <a:rPr sz="1100">
+                        <a:rPr sz="1400">
                           <a:solidFill>
                             <a:srgbClr val="1F1F2E"/>
                           </a:solidFill>
@@ -8066,7 +8787,7 @@
                     <a:lstStyle/>
                     <a:p>
                       <a:r>
-                        <a:rPr sz="1100">
+                        <a:rPr sz="1400">
                           <a:solidFill>
                             <a:srgbClr val="1F1F2E"/>
                           </a:solidFill>
@@ -8087,7 +8808,7 @@
                     <a:lstStyle/>
                     <a:p>
                       <a:r>
-                        <a:rPr sz="1100">
+                        <a:rPr sz="1400">
                           <a:solidFill>
                             <a:srgbClr val="1F1F2E"/>
                           </a:solidFill>
@@ -8108,7 +8829,7 @@
                     <a:lstStyle/>
                     <a:p>
                       <a:r>
-                        <a:rPr sz="1100">
+                        <a:rPr sz="1400">
                           <a:solidFill>
                             <a:srgbClr val="1F1F2E"/>
                           </a:solidFill>
@@ -8129,7 +8850,7 @@
                     <a:lstStyle/>
                     <a:p>
                       <a:r>
-                        <a:rPr sz="1100">
+                        <a:rPr sz="1400">
                           <a:solidFill>
                             <a:srgbClr val="1F1F2E"/>
                           </a:solidFill>
@@ -8157,7 +8878,7 @@
                     <a:lstStyle/>
                     <a:p>
                       <a:r>
-                        <a:rPr sz="1100">
+                        <a:rPr sz="1400">
                           <a:solidFill>
                             <a:srgbClr val="1F1F2E"/>
                           </a:solidFill>
@@ -8178,7 +8899,7 @@
                     <a:lstStyle/>
                     <a:p>
                       <a:r>
-                        <a:rPr sz="1100">
+                        <a:rPr sz="1400">
                           <a:solidFill>
                             <a:srgbClr val="1F1F2E"/>
                           </a:solidFill>
@@ -8199,7 +8920,7 @@
                     <a:lstStyle/>
                     <a:p>
                       <a:r>
-                        <a:rPr sz="1100">
+                        <a:rPr sz="1400">
                           <a:solidFill>
                             <a:srgbClr val="1F1F2E"/>
                           </a:solidFill>
@@ -8220,7 +8941,7 @@
                     <a:lstStyle/>
                     <a:p>
                       <a:r>
-                        <a:rPr sz="1100">
+                        <a:rPr sz="1400">
                           <a:solidFill>
                             <a:srgbClr val="1F1F2E"/>
                           </a:solidFill>
@@ -8248,7 +8969,7 @@
                     <a:lstStyle/>
                     <a:p>
                       <a:r>
-                        <a:rPr sz="1100">
+                        <a:rPr sz="1400">
                           <a:solidFill>
                             <a:srgbClr val="1F1F2E"/>
                           </a:solidFill>
@@ -8269,7 +8990,7 @@
                     <a:lstStyle/>
                     <a:p>
                       <a:r>
-                        <a:rPr sz="1100">
+                        <a:rPr sz="1400">
                           <a:solidFill>
                             <a:srgbClr val="1F1F2E"/>
                           </a:solidFill>
@@ -8290,7 +9011,7 @@
                     <a:lstStyle/>
                     <a:p>
                       <a:r>
-                        <a:rPr sz="1100">
+                        <a:rPr sz="1400">
                           <a:solidFill>
                             <a:srgbClr val="1F1F2E"/>
                           </a:solidFill>
@@ -8311,7 +9032,7 @@
                     <a:lstStyle/>
                     <a:p>
                       <a:r>
-                        <a:rPr sz="1100">
+                        <a:rPr sz="1400">
                           <a:solidFill>
                             <a:srgbClr val="1F1F2E"/>
                           </a:solidFill>
@@ -8339,7 +9060,7 @@
                     <a:lstStyle/>
                     <a:p>
                       <a:r>
-                        <a:rPr sz="1100">
+                        <a:rPr sz="1400">
                           <a:solidFill>
                             <a:srgbClr val="1F1F2E"/>
                           </a:solidFill>
@@ -8360,7 +9081,7 @@
                     <a:lstStyle/>
                     <a:p>
                       <a:r>
-                        <a:rPr sz="1100">
+                        <a:rPr sz="1400">
                           <a:solidFill>
                             <a:srgbClr val="1F1F2E"/>
                           </a:solidFill>
@@ -8381,7 +9102,7 @@
                     <a:lstStyle/>
                     <a:p>
                       <a:r>
-                        <a:rPr sz="1100">
+                        <a:rPr sz="1400">
                           <a:solidFill>
                             <a:srgbClr val="1F1F2E"/>
                           </a:solidFill>
@@ -8402,7 +9123,7 @@
                     <a:lstStyle/>
                     <a:p>
                       <a:r>
-                        <a:rPr sz="1100">
+                        <a:rPr sz="1400" dirty="0">
                           <a:solidFill>
                             <a:srgbClr val="1F1F2E"/>
                           </a:solidFill>
@@ -8436,7 +9157,7 @@
         <p:spPr>
           <a:xfrm>
             <a:off x="500000" y="5908000"/>
-            <a:ext cx="11192000" cy="400000"/>
+            <a:ext cx="11192000" cy="307777"/>
           </a:xfrm>
           <a:prstGeom prst="rect">
             <a:avLst/>
@@ -8450,13 +9171,138 @@
           <a:lstStyle/>
           <a:p>
             <a:r>
-              <a:rPr sz="1200" i="1">
+              <a:rPr sz="1400" i="1" dirty="0">
                 <a:solidFill>
                   <a:srgbClr val="555566"/>
                 </a:solidFill>
               </a:rPr>
-              <a:t>MDI-QKD (Measurement-Device-Independent) усуває усі атаки на детектори — центральний вузол недовірений</a:t>
-            </a:r>
+              <a:t>MDI-QKD (Measurement-Device-Independent) </a:t>
+            </a:r>
+            <a:r>
+              <a:rPr sz="1400" i="1" dirty="0" err="1">
+                <a:solidFill>
+                  <a:srgbClr val="555566"/>
+                </a:solidFill>
+              </a:rPr>
+              <a:t>усуває</a:t>
+            </a:r>
+            <a:r>
+              <a:rPr sz="1400" i="1" dirty="0">
+                <a:solidFill>
+                  <a:srgbClr val="555566"/>
+                </a:solidFill>
+              </a:rPr>
+              <a:t> </a:t>
+            </a:r>
+            <a:r>
+              <a:rPr sz="1400" i="1" dirty="0" err="1">
+                <a:solidFill>
+                  <a:srgbClr val="555566"/>
+                </a:solidFill>
+              </a:rPr>
+              <a:t>усі</a:t>
+            </a:r>
+            <a:r>
+              <a:rPr sz="1400" i="1" dirty="0">
+                <a:solidFill>
+                  <a:srgbClr val="555566"/>
+                </a:solidFill>
+              </a:rPr>
+              <a:t> </a:t>
+            </a:r>
+            <a:r>
+              <a:rPr sz="1400" i="1" dirty="0" err="1">
+                <a:solidFill>
+                  <a:srgbClr val="555566"/>
+                </a:solidFill>
+              </a:rPr>
+              <a:t>атаки</a:t>
+            </a:r>
+            <a:r>
+              <a:rPr sz="1400" i="1" dirty="0">
+                <a:solidFill>
+                  <a:srgbClr val="555566"/>
+                </a:solidFill>
+              </a:rPr>
+              <a:t> </a:t>
+            </a:r>
+            <a:r>
+              <a:rPr sz="1400" i="1" dirty="0" err="1">
+                <a:solidFill>
+                  <a:srgbClr val="555566"/>
+                </a:solidFill>
+              </a:rPr>
+              <a:t>на</a:t>
+            </a:r>
+            <a:r>
+              <a:rPr sz="1400" i="1" dirty="0">
+                <a:solidFill>
+                  <a:srgbClr val="555566"/>
+                </a:solidFill>
+              </a:rPr>
+              <a:t> </a:t>
+            </a:r>
+            <a:r>
+              <a:rPr sz="1400" i="1" dirty="0" err="1">
+                <a:solidFill>
+                  <a:srgbClr val="555566"/>
+                </a:solidFill>
+              </a:rPr>
+              <a:t>детектори</a:t>
+            </a:r>
+            <a:r>
+              <a:rPr sz="1400" i="1" dirty="0">
+                <a:solidFill>
+                  <a:srgbClr val="555566"/>
+                </a:solidFill>
+              </a:rPr>
+              <a:t> — </a:t>
+            </a:r>
+            <a:r>
+              <a:rPr sz="1400" i="1" dirty="0" err="1">
+                <a:solidFill>
+                  <a:srgbClr val="555566"/>
+                </a:solidFill>
+              </a:rPr>
+              <a:t>центральний</a:t>
+            </a:r>
+            <a:r>
+              <a:rPr sz="1400" i="1" dirty="0">
+                <a:solidFill>
+                  <a:srgbClr val="555566"/>
+                </a:solidFill>
+              </a:rPr>
+              <a:t> </a:t>
+            </a:r>
+            <a:r>
+              <a:rPr sz="1400" i="1" dirty="0" err="1">
+                <a:solidFill>
+                  <a:srgbClr val="555566"/>
+                </a:solidFill>
+              </a:rPr>
+              <a:t>вузол</a:t>
+            </a:r>
+            <a:r>
+              <a:rPr sz="1400" i="1" dirty="0">
+                <a:solidFill>
+                  <a:srgbClr val="555566"/>
+                </a:solidFill>
+              </a:rPr>
+              <a:t> </a:t>
+            </a:r>
+            <a:r>
+              <a:rPr sz="1400" i="1" dirty="0" err="1">
+                <a:solidFill>
+                  <a:srgbClr val="555566"/>
+                </a:solidFill>
+              </a:rPr>
+              <a:t>недовірений</a:t>
+            </a:r>
+            <a:endParaRPr sz="1400" i="1" dirty="0">
+              <a:solidFill>
+                <a:srgbClr val="555566"/>
+              </a:solidFill>
+            </a:endParaRPr>
           </a:p>
         </p:txBody>
       </p:sp>
@@ -8621,7 +9467,13 @@
           <p:cNvGraphicFramePr>
             <a:graphicFrameLocks noGrp="1"/>
           </p:cNvGraphicFramePr>
-          <p:nvPr/>
+          <p:nvPr>
+            <p:extLst>
+              <p:ext uri="{D42A27DB-BD31-4B8C-83A1-F6EECF244321}">
+                <p14:modId xmlns:p14="http://schemas.microsoft.com/office/powerpoint/2010/main" val="3677473408"/>
+              </p:ext>
+            </p:extLst>
+          </p:nvPr>
         </p:nvGraphicFramePr>
         <p:xfrm>
           <a:off x="500000" y="1750000"/>
@@ -8677,13 +9529,18 @@
                     <a:lstStyle/>
                     <a:p>
                       <a:r>
-                        <a:rPr sz="1300" b="1">
+                        <a:rPr sz="1600" b="1" dirty="0" err="1">
                           <a:solidFill>
                             <a:srgbClr val="FFFFFF"/>
                           </a:solidFill>
                         </a:rPr>
                         <a:t>Виробник</a:t>
                       </a:r>
+                      <a:endParaRPr sz="1600" b="1" dirty="0">
+                        <a:solidFill>
+                          <a:srgbClr val="FFFFFF"/>
+                        </a:solidFill>
+                      </a:endParaRPr>
                     </a:p>
                   </a:txBody>
                   <a:tcPr>
@@ -8698,7 +9555,7 @@
                     <a:lstStyle/>
                     <a:p>
                       <a:r>
-                        <a:rPr sz="1300" b="1">
+                        <a:rPr sz="1600" b="1">
                           <a:solidFill>
                             <a:srgbClr val="FFFFFF"/>
                           </a:solidFill>
@@ -8719,7 +9576,7 @@
                     <a:lstStyle/>
                     <a:p>
                       <a:r>
-                        <a:rPr sz="1300" b="1">
+                        <a:rPr sz="1600" b="1">
                           <a:solidFill>
                             <a:srgbClr val="FFFFFF"/>
                           </a:solidFill>
@@ -8740,7 +9597,7 @@
                     <a:lstStyle/>
                     <a:p>
                       <a:r>
-                        <a:rPr sz="1300" b="1">
+                        <a:rPr sz="1600" b="1">
                           <a:solidFill>
                             <a:srgbClr val="FFFFFF"/>
                           </a:solidFill>
@@ -8761,7 +9618,7 @@
                     <a:lstStyle/>
                     <a:p>
                       <a:r>
-                        <a:rPr sz="1300" b="1">
+                        <a:rPr sz="1600" b="1">
                           <a:solidFill>
                             <a:srgbClr val="FFFFFF"/>
                           </a:solidFill>
@@ -8789,7 +9646,7 @@
                     <a:lstStyle/>
                     <a:p>
                       <a:r>
-                        <a:rPr sz="1100">
+                        <a:rPr sz="1400">
                           <a:solidFill>
                             <a:srgbClr val="1F1F2E"/>
                           </a:solidFill>
@@ -8810,7 +9667,7 @@
                     <a:lstStyle/>
                     <a:p>
                       <a:r>
-                        <a:rPr sz="1100">
+                        <a:rPr sz="1400">
                           <a:solidFill>
                             <a:srgbClr val="1F1F2E"/>
                           </a:solidFill>
@@ -8831,7 +9688,7 @@
                     <a:lstStyle/>
                     <a:p>
                       <a:r>
-                        <a:rPr sz="1100">
+                        <a:rPr sz="1400">
                           <a:solidFill>
                             <a:srgbClr val="1F1F2E"/>
                           </a:solidFill>
@@ -8852,7 +9709,7 @@
                     <a:lstStyle/>
                     <a:p>
                       <a:r>
-                        <a:rPr sz="1100">
+                        <a:rPr sz="1400">
                           <a:solidFill>
                             <a:srgbClr val="1F1F2E"/>
                           </a:solidFill>
@@ -8873,7 +9730,7 @@
                     <a:lstStyle/>
                     <a:p>
                       <a:r>
-                        <a:rPr sz="1100">
+                        <a:rPr sz="1400">
                           <a:solidFill>
                             <a:srgbClr val="1F1F2E"/>
                           </a:solidFill>
@@ -8901,7 +9758,7 @@
                     <a:lstStyle/>
                     <a:p>
                       <a:r>
-                        <a:rPr sz="1100">
+                        <a:rPr sz="1400">
                           <a:solidFill>
                             <a:srgbClr val="1F1F2E"/>
                           </a:solidFill>
@@ -8922,7 +9779,7 @@
                     <a:lstStyle/>
                     <a:p>
                       <a:r>
-                        <a:rPr sz="1100">
+                        <a:rPr sz="1400">
                           <a:solidFill>
                             <a:srgbClr val="1F1F2E"/>
                           </a:solidFill>
@@ -8943,7 +9800,7 @@
                     <a:lstStyle/>
                     <a:p>
                       <a:r>
-                        <a:rPr sz="1100">
+                        <a:rPr sz="1400">
                           <a:solidFill>
                             <a:srgbClr val="1F1F2E"/>
                           </a:solidFill>
@@ -8964,7 +9821,7 @@
                     <a:lstStyle/>
                     <a:p>
                       <a:r>
-                        <a:rPr sz="1100">
+                        <a:rPr sz="1400">
                           <a:solidFill>
                             <a:srgbClr val="1F1F2E"/>
                           </a:solidFill>
@@ -8985,7 +9842,7 @@
                     <a:lstStyle/>
                     <a:p>
                       <a:r>
-                        <a:rPr sz="1100">
+                        <a:rPr sz="1400">
                           <a:solidFill>
                             <a:srgbClr val="1F1F2E"/>
                           </a:solidFill>
@@ -9013,7 +9870,7 @@
                     <a:lstStyle/>
                     <a:p>
                       <a:r>
-                        <a:rPr sz="1100">
+                        <a:rPr sz="1400">
                           <a:solidFill>
                             <a:srgbClr val="1F1F2E"/>
                           </a:solidFill>
@@ -9034,7 +9891,7 @@
                     <a:lstStyle/>
                     <a:p>
                       <a:r>
-                        <a:rPr sz="1100">
+                        <a:rPr sz="1400">
                           <a:solidFill>
                             <a:srgbClr val="1F1F2E"/>
                           </a:solidFill>
@@ -9055,7 +9912,7 @@
                     <a:lstStyle/>
                     <a:p>
                       <a:r>
-                        <a:rPr sz="1100">
+                        <a:rPr sz="1400">
                           <a:solidFill>
                             <a:srgbClr val="1F1F2E"/>
                           </a:solidFill>
@@ -9076,7 +9933,7 @@
                     <a:lstStyle/>
                     <a:p>
                       <a:r>
-                        <a:rPr sz="1100">
+                        <a:rPr sz="1400">
                           <a:solidFill>
                             <a:srgbClr val="1F1F2E"/>
                           </a:solidFill>
@@ -9097,7 +9954,7 @@
                     <a:lstStyle/>
                     <a:p>
                       <a:r>
-                        <a:rPr sz="1100">
+                        <a:rPr sz="1400">
                           <a:solidFill>
                             <a:srgbClr val="1F1F2E"/>
                           </a:solidFill>
@@ -9125,7 +9982,7 @@
                     <a:lstStyle/>
                     <a:p>
                       <a:r>
-                        <a:rPr sz="1100">
+                        <a:rPr sz="1400">
                           <a:solidFill>
                             <a:srgbClr val="1F1F2E"/>
                           </a:solidFill>
@@ -9146,7 +10003,7 @@
                     <a:lstStyle/>
                     <a:p>
                       <a:r>
-                        <a:rPr sz="1100">
+                        <a:rPr sz="1400">
                           <a:solidFill>
                             <a:srgbClr val="1F1F2E"/>
                           </a:solidFill>
@@ -9167,7 +10024,7 @@
                     <a:lstStyle/>
                     <a:p>
                       <a:r>
-                        <a:rPr sz="1100">
+                        <a:rPr sz="1400">
                           <a:solidFill>
                             <a:srgbClr val="1F1F2E"/>
                           </a:solidFill>
@@ -9188,7 +10045,7 @@
                     <a:lstStyle/>
                     <a:p>
                       <a:r>
-                        <a:rPr sz="1100">
+                        <a:rPr sz="1400">
                           <a:solidFill>
                             <a:srgbClr val="1F1F2E"/>
                           </a:solidFill>
@@ -9209,7 +10066,7 @@
                     <a:lstStyle/>
                     <a:p>
                       <a:r>
-                        <a:rPr sz="1100">
+                        <a:rPr sz="1400">
                           <a:solidFill>
                             <a:srgbClr val="1F1F2E"/>
                           </a:solidFill>
@@ -9237,7 +10094,7 @@
                     <a:lstStyle/>
                     <a:p>
                       <a:r>
-                        <a:rPr sz="1100">
+                        <a:rPr sz="1400">
                           <a:solidFill>
                             <a:srgbClr val="1F1F2E"/>
                           </a:solidFill>
@@ -9258,7 +10115,7 @@
                     <a:lstStyle/>
                     <a:p>
                       <a:r>
-                        <a:rPr sz="1100">
+                        <a:rPr sz="1400">
                           <a:solidFill>
                             <a:srgbClr val="1F1F2E"/>
                           </a:solidFill>
@@ -9279,7 +10136,7 @@
                     <a:lstStyle/>
                     <a:p>
                       <a:r>
-                        <a:rPr sz="1100">
+                        <a:rPr sz="1400">
                           <a:solidFill>
                             <a:srgbClr val="1F1F2E"/>
                           </a:solidFill>
@@ -9300,7 +10157,7 @@
                     <a:lstStyle/>
                     <a:p>
                       <a:r>
-                        <a:rPr sz="1100">
+                        <a:rPr sz="1400">
                           <a:solidFill>
                             <a:srgbClr val="1F1F2E"/>
                           </a:solidFill>
@@ -9321,7 +10178,7 @@
                     <a:lstStyle/>
                     <a:p>
                       <a:r>
-                        <a:rPr sz="1100">
+                        <a:rPr sz="1400">
                           <a:solidFill>
                             <a:srgbClr val="1F1F2E"/>
                           </a:solidFill>
@@ -9349,7 +10206,7 @@
                     <a:lstStyle/>
                     <a:p>
                       <a:r>
-                        <a:rPr sz="1100">
+                        <a:rPr sz="1400">
                           <a:solidFill>
                             <a:srgbClr val="1F1F2E"/>
                           </a:solidFill>
@@ -9370,7 +10227,7 @@
                     <a:lstStyle/>
                     <a:p>
                       <a:r>
-                        <a:rPr sz="1100">
+                        <a:rPr sz="1400">
                           <a:solidFill>
                             <a:srgbClr val="1F1F2E"/>
                           </a:solidFill>
@@ -9391,7 +10248,7 @@
                     <a:lstStyle/>
                     <a:p>
                       <a:r>
-                        <a:rPr sz="1100">
+                        <a:rPr sz="1400">
                           <a:solidFill>
                             <a:srgbClr val="1F1F2E"/>
                           </a:solidFill>
@@ -9412,7 +10269,7 @@
                     <a:lstStyle/>
                     <a:p>
                       <a:r>
-                        <a:rPr sz="1100">
+                        <a:rPr sz="1400">
                           <a:solidFill>
                             <a:srgbClr val="1F1F2E"/>
                           </a:solidFill>
@@ -9433,7 +10290,7 @@
                     <a:lstStyle/>
                     <a:p>
                       <a:r>
-                        <a:rPr sz="1100">
+                        <a:rPr sz="1400">
                           <a:solidFill>
                             <a:srgbClr val="1F1F2E"/>
                           </a:solidFill>
@@ -9461,7 +10318,7 @@
                     <a:lstStyle/>
                     <a:p>
                       <a:r>
-                        <a:rPr sz="1100">
+                        <a:rPr sz="1400">
                           <a:solidFill>
                             <a:srgbClr val="1F1F2E"/>
                           </a:solidFill>
@@ -9482,7 +10339,7 @@
                     <a:lstStyle/>
                     <a:p>
                       <a:r>
-                        <a:rPr sz="1100">
+                        <a:rPr sz="1400">
                           <a:solidFill>
                             <a:srgbClr val="1F1F2E"/>
                           </a:solidFill>
@@ -9503,7 +10360,7 @@
                     <a:lstStyle/>
                     <a:p>
                       <a:r>
-                        <a:rPr sz="1100">
+                        <a:rPr sz="1400">
                           <a:solidFill>
                             <a:srgbClr val="1F1F2E"/>
                           </a:solidFill>
@@ -9524,7 +10381,7 @@
                     <a:lstStyle/>
                     <a:p>
                       <a:r>
-                        <a:rPr sz="1100">
+                        <a:rPr sz="1400">
                           <a:solidFill>
                             <a:srgbClr val="1F1F2E"/>
                           </a:solidFill>
@@ -9545,7 +10402,7 @@
                     <a:lstStyle/>
                     <a:p>
                       <a:r>
-                        <a:rPr sz="1100">
+                        <a:rPr sz="1400">
                           <a:solidFill>
                             <a:srgbClr val="1F1F2E"/>
                           </a:solidFill>
@@ -9573,7 +10430,7 @@
                     <a:lstStyle/>
                     <a:p>
                       <a:r>
-                        <a:rPr sz="1100">
+                        <a:rPr sz="1400">
                           <a:solidFill>
                             <a:srgbClr val="1F1F2E"/>
                           </a:solidFill>
@@ -9594,7 +10451,7 @@
                     <a:lstStyle/>
                     <a:p>
                       <a:r>
-                        <a:rPr sz="1100">
+                        <a:rPr sz="1400">
                           <a:solidFill>
                             <a:srgbClr val="1F1F2E"/>
                           </a:solidFill>
@@ -9615,7 +10472,7 @@
                     <a:lstStyle/>
                     <a:p>
                       <a:r>
-                        <a:rPr sz="1100">
+                        <a:rPr sz="1400">
                           <a:solidFill>
                             <a:srgbClr val="1F1F2E"/>
                           </a:solidFill>
@@ -9636,7 +10493,7 @@
                     <a:lstStyle/>
                     <a:p>
                       <a:r>
-                        <a:rPr sz="1100">
+                        <a:rPr sz="1400">
                           <a:solidFill>
                             <a:srgbClr val="1F1F2E"/>
                           </a:solidFill>
@@ -9657,13 +10514,18 @@
                     <a:lstStyle/>
                     <a:p>
                       <a:r>
-                        <a:rPr sz="1100">
+                        <a:rPr sz="1400" dirty="0" err="1">
                           <a:solidFill>
                             <a:srgbClr val="1F1F2E"/>
                           </a:solidFill>
                         </a:rPr>
                         <a:t>серверний</a:t>
                       </a:r>
+                      <a:endParaRPr sz="1400" dirty="0">
+                        <a:solidFill>
+                          <a:srgbClr val="1F1F2E"/>
+                        </a:solidFill>
+                      </a:endParaRPr>
                     </a:p>
                   </a:txBody>
                   <a:tcPr>
@@ -9691,7 +10553,7 @@
         <p:spPr>
           <a:xfrm>
             <a:off x="500000" y="5908000"/>
-            <a:ext cx="11192000" cy="400000"/>
+            <a:ext cx="11192000" cy="307777"/>
           </a:xfrm>
           <a:prstGeom prst="rect">
             <a:avLst/>
@@ -9705,12 +10567,52 @@
           <a:lstStyle/>
           <a:p>
             <a:r>
-              <a:rPr sz="1200" i="1">
+              <a:rPr sz="1400" i="1" dirty="0" err="1">
                 <a:solidFill>
                   <a:srgbClr val="555566"/>
                 </a:solidFill>
               </a:rPr>
-              <a:t>Стандарти: ETSI ISG-QKD, ITU-T Y.3800 (QKDN). Мережі: EuroQCI, Tokyo QKD, Beijing-Shanghai</a:t>
+              <a:t>Стандарти</a:t>
+            </a:r>
+            <a:r>
+              <a:rPr sz="1400" i="1" dirty="0">
+                <a:solidFill>
+                  <a:srgbClr val="555566"/>
+                </a:solidFill>
+              </a:rPr>
+              <a:t>: ETSI ISG-QKD, ITU-T Y.3800 (QKDN). </a:t>
+            </a:r>
+            <a:r>
+              <a:rPr sz="1400" i="1" dirty="0" err="1">
+                <a:solidFill>
+                  <a:srgbClr val="555566"/>
+                </a:solidFill>
+              </a:rPr>
+              <a:t>Мережі</a:t>
+            </a:r>
+            <a:r>
+              <a:rPr sz="1400" i="1" dirty="0">
+                <a:solidFill>
+                  <a:srgbClr val="555566"/>
+                </a:solidFill>
+              </a:rPr>
+              <a:t>: </a:t>
+            </a:r>
+            <a:r>
+              <a:rPr sz="1400" i="1" dirty="0" err="1">
+                <a:solidFill>
+                  <a:srgbClr val="555566"/>
+                </a:solidFill>
+              </a:rPr>
+              <a:t>EuroQCI</a:t>
+            </a:r>
+            <a:r>
+              <a:rPr sz="1400" i="1" dirty="0">
+                <a:solidFill>
+                  <a:srgbClr val="555566"/>
+                </a:solidFill>
+              </a:rPr>
+              <a:t>, Tokyo QKD, Beijing-Shanghai</a:t>
             </a:r>
           </a:p>
         </p:txBody>
@@ -9913,13 +10815,34 @@
           <a:p>
             <a:pPr algn="ctr"/>
             <a:r>
-              <a:rPr sz="1800" b="1">
+              <a:rPr sz="1800" b="1" dirty="0" err="1">
                 <a:solidFill>
                   <a:srgbClr val="FFFFFF"/>
                 </a:solidFill>
               </a:rPr>
-              <a:t>Що вивчили</a:t>
-            </a:r>
+              <a:t>Що</a:t>
+            </a:r>
+            <a:r>
+              <a:rPr sz="1800" b="1" dirty="0">
+                <a:solidFill>
+                  <a:srgbClr val="FFFFFF"/>
+                </a:solidFill>
+              </a:rPr>
+              <a:t> </a:t>
+            </a:r>
+            <a:r>
+              <a:rPr sz="1800" b="1" dirty="0" err="1">
+                <a:solidFill>
+                  <a:srgbClr val="FFFFFF"/>
+                </a:solidFill>
+              </a:rPr>
+              <a:t>вивчили</a:t>
+            </a:r>
+            <a:endParaRPr sz="1800" b="1" dirty="0">
+              <a:solidFill>
+                <a:srgbClr val="FFFFFF"/>
+              </a:solidFill>
+            </a:endParaRPr>
           </a:p>
         </p:txBody>
       </p:sp>
@@ -9965,57 +10888,131 @@
           <a:lstStyle/>
           <a:p>
             <a:r>
-              <a:rPr sz="1300">
+              <a:rPr dirty="0">
                 <a:solidFill>
                   <a:srgbClr val="222233"/>
                 </a:solidFill>
               </a:rPr>
-              <a:t>•  Принципи QKD: no-cloning, MUB</a:t>
-            </a:r>
-          </a:p>
-          <a:p>
-            <a:r>
-              <a:rPr sz="1300">
+              <a:t>•  </a:t>
+            </a:r>
+            <a:r>
+              <a:rPr dirty="0" err="1">
                 <a:solidFill>
                   <a:srgbClr val="222233"/>
                 </a:solidFill>
               </a:rPr>
-              <a:t>•  BB84: 4 стани, 8 кроків</a:t>
-            </a:r>
-          </a:p>
-          <a:p>
-            <a:r>
-              <a:rPr sz="1300">
+              <a:t>Принципи</a:t>
+            </a:r>
+            <a:r>
+              <a:rPr dirty="0">
                 <a:solidFill>
                   <a:srgbClr val="222233"/>
                 </a:solidFill>
               </a:rPr>
-              <a:t>•  QBER, Eve-detection, безпека</a:t>
-            </a:r>
-          </a:p>
-          <a:p>
-            <a:r>
-              <a:rPr sz="1300">
+              <a:t> QKD: no-cloning, MUB</a:t>
+            </a:r>
+          </a:p>
+          <a:p>
+            <a:r>
+              <a:rPr dirty="0">
                 <a:solidFill>
                   <a:srgbClr val="222233"/>
                 </a:solidFill>
               </a:rPr>
+              <a:t>•  BB84: 4 </a:t>
+            </a:r>
+            <a:r>
+              <a:rPr dirty="0" err="1">
+                <a:solidFill>
+                  <a:srgbClr val="222233"/>
+                </a:solidFill>
+              </a:rPr>
+              <a:t>стани</a:t>
+            </a:r>
+            <a:r>
+              <a:rPr dirty="0">
+                <a:solidFill>
+                  <a:srgbClr val="222233"/>
+                </a:solidFill>
+              </a:rPr>
+              <a:t>, 8 </a:t>
+            </a:r>
+            <a:r>
+              <a:rPr dirty="0" err="1">
+                <a:solidFill>
+                  <a:srgbClr val="222233"/>
+                </a:solidFill>
+              </a:rPr>
+              <a:t>кроків</a:t>
+            </a:r>
+            <a:endParaRPr dirty="0">
+              <a:solidFill>
+                <a:srgbClr val="222233"/>
+              </a:solidFill>
+            </a:endParaRPr>
+          </a:p>
+          <a:p>
+            <a:r>
+              <a:rPr dirty="0">
+                <a:solidFill>
+                  <a:srgbClr val="222233"/>
+                </a:solidFill>
+              </a:rPr>
+              <a:t>•  QBER, Eve-detection, </a:t>
+            </a:r>
+            <a:r>
+              <a:rPr dirty="0" err="1">
+                <a:solidFill>
+                  <a:srgbClr val="222233"/>
+                </a:solidFill>
+              </a:rPr>
+              <a:t>безпека</a:t>
+            </a:r>
+            <a:endParaRPr dirty="0">
+              <a:solidFill>
+                <a:srgbClr val="222233"/>
+              </a:solidFill>
+            </a:endParaRPr>
+          </a:p>
+          <a:p>
+            <a:r>
+              <a:rPr dirty="0">
+                <a:solidFill>
+                  <a:srgbClr val="222233"/>
+                </a:solidFill>
+              </a:rPr>
               <a:t>•  Error correction (Cascade/LDPC)</a:t>
             </a:r>
           </a:p>
           <a:p>
             <a:r>
-              <a:rPr sz="1300">
+              <a:rPr dirty="0">
                 <a:solidFill>
                   <a:srgbClr val="222233"/>
                 </a:solidFill>
               </a:rPr>
-              <a:t>•  Privacy amplification (хеш-функції)</a:t>
-            </a:r>
-          </a:p>
-          <a:p>
-            <a:r>
-              <a:rPr sz="1300">
+              <a:t>•  Privacy amplification (</a:t>
+            </a:r>
+            <a:r>
+              <a:rPr dirty="0" err="1">
+                <a:solidFill>
+                  <a:srgbClr val="222233"/>
+                </a:solidFill>
+              </a:rPr>
+              <a:t>хеш-функції</a:t>
+            </a:r>
+            <a:r>
+              <a:rPr dirty="0">
+                <a:solidFill>
+                  <a:srgbClr val="222233"/>
+                </a:solidFill>
+              </a:rPr>
+              <a:t>)</a:t>
+            </a:r>
+          </a:p>
+          <a:p>
+            <a:r>
+              <a:rPr dirty="0">
                 <a:solidFill>
                   <a:srgbClr val="222233"/>
                 </a:solidFill>
@@ -10120,7 +11117,7 @@
           <a:lstStyle/>
           <a:p>
             <a:r>
-              <a:rPr sz="1300">
+              <a:rPr>
                 <a:solidFill>
                   <a:srgbClr val="222233"/>
                 </a:solidFill>
@@ -10130,7 +11127,7 @@
           </a:p>
           <a:p>
             <a:r>
-              <a:rPr sz="1300">
+              <a:rPr>
                 <a:solidFill>
                   <a:srgbClr val="222233"/>
                 </a:solidFill>
@@ -10140,7 +11137,7 @@
           </a:p>
           <a:p>
             <a:r>
-              <a:rPr sz="1300">
+              <a:rPr>
                 <a:solidFill>
                   <a:srgbClr val="222233"/>
                 </a:solidFill>
@@ -10150,7 +11147,7 @@
           </a:p>
           <a:p>
             <a:r>
-              <a:rPr sz="1300">
+              <a:rPr>
                 <a:solidFill>
                   <a:srgbClr val="222233"/>
                 </a:solidFill>
@@ -10160,7 +11157,7 @@
           </a:p>
           <a:p>
             <a:r>
-              <a:rPr sz="1300">
+              <a:rPr>
                 <a:solidFill>
                   <a:srgbClr val="222233"/>
                 </a:solidFill>
@@ -10170,7 +11167,7 @@
           </a:p>
           <a:p>
             <a:r>
-              <a:rPr sz="1300">
+              <a:rPr>
                 <a:solidFill>
                   <a:srgbClr val="222233"/>
                 </a:solidFill>
@@ -10204,13 +11201,186 @@
           <a:p>
             <a:pPr algn="ctr"/>
             <a:r>
-              <a:rPr sz="1400" b="1">
+              <a:rPr sz="1400" b="1" dirty="0">
                 <a:solidFill>
                   <a:srgbClr val="445577"/>
                 </a:solidFill>
               </a:rPr>
-              <a:t>QKD захищає ключ фізикою; PQC захищає ключ математикою — разом це захист у глибину</a:t>
-            </a:r>
+              <a:t>QKD </a:t>
+            </a:r>
+            <a:r>
+              <a:rPr sz="1400" b="1" dirty="0" err="1">
+                <a:solidFill>
+                  <a:srgbClr val="445577"/>
+                </a:solidFill>
+              </a:rPr>
+              <a:t>захищає</a:t>
+            </a:r>
+            <a:r>
+              <a:rPr sz="1400" b="1" dirty="0">
+                <a:solidFill>
+                  <a:srgbClr val="445577"/>
+                </a:solidFill>
+              </a:rPr>
+              <a:t> </a:t>
+            </a:r>
+            <a:r>
+              <a:rPr sz="1400" b="1" dirty="0" err="1">
+                <a:solidFill>
+                  <a:srgbClr val="445577"/>
+                </a:solidFill>
+              </a:rPr>
+              <a:t>ключ</a:t>
+            </a:r>
+            <a:r>
+              <a:rPr sz="1400" b="1" dirty="0">
+                <a:solidFill>
+                  <a:srgbClr val="445577"/>
+                </a:solidFill>
+              </a:rPr>
+              <a:t> </a:t>
+            </a:r>
+            <a:r>
+              <a:rPr sz="1400" b="1" dirty="0" err="1">
+                <a:solidFill>
+                  <a:srgbClr val="445577"/>
+                </a:solidFill>
+              </a:rPr>
+              <a:t>фізикою</a:t>
+            </a:r>
+            <a:r>
+              <a:rPr sz="1400" b="1" dirty="0">
+                <a:solidFill>
+                  <a:srgbClr val="445577"/>
+                </a:solidFill>
+              </a:rPr>
+              <a:t>; PQC </a:t>
+            </a:r>
+            <a:r>
+              <a:rPr sz="1400" b="1" dirty="0" err="1">
+                <a:solidFill>
+                  <a:srgbClr val="445577"/>
+                </a:solidFill>
+              </a:rPr>
+              <a:t>захищає</a:t>
+            </a:r>
+            <a:r>
+              <a:rPr sz="1400" b="1" dirty="0">
+                <a:solidFill>
+                  <a:srgbClr val="445577"/>
+                </a:solidFill>
+              </a:rPr>
+              <a:t> </a:t>
+            </a:r>
+            <a:r>
+              <a:rPr sz="1400" b="1" dirty="0" err="1">
+                <a:solidFill>
+                  <a:srgbClr val="445577"/>
+                </a:solidFill>
+              </a:rPr>
+              <a:t>ключ</a:t>
+            </a:r>
+            <a:r>
+              <a:rPr sz="1400" b="1" dirty="0">
+                <a:solidFill>
+                  <a:srgbClr val="445577"/>
+                </a:solidFill>
+              </a:rPr>
+              <a:t> </a:t>
+            </a:r>
+            <a:r>
+              <a:rPr sz="1400" b="1" dirty="0" err="1">
+                <a:solidFill>
+                  <a:srgbClr val="445577"/>
+                </a:solidFill>
+              </a:rPr>
+              <a:t>математикою</a:t>
+            </a:r>
+            <a:r>
+              <a:rPr sz="1400" b="1" dirty="0">
+                <a:solidFill>
+                  <a:srgbClr val="445577"/>
+                </a:solidFill>
+              </a:rPr>
+              <a:t> — </a:t>
+            </a:r>
+            <a:r>
+              <a:rPr sz="1400" b="1" dirty="0" err="1">
+                <a:solidFill>
+                  <a:srgbClr val="445577"/>
+                </a:solidFill>
+              </a:rPr>
+              <a:t>разом</a:t>
+            </a:r>
+            <a:r>
+              <a:rPr sz="1400" b="1" dirty="0">
+                <a:solidFill>
+                  <a:srgbClr val="445577"/>
+                </a:solidFill>
+              </a:rPr>
+              <a:t> </a:t>
+            </a:r>
+            <a:r>
+              <a:rPr sz="1400" b="1" dirty="0" err="1">
+                <a:solidFill>
+                  <a:srgbClr val="445577"/>
+                </a:solidFill>
+              </a:rPr>
+              <a:t>це</a:t>
+            </a:r>
+            <a:r>
+              <a:rPr sz="1400" b="1" dirty="0">
+                <a:solidFill>
+                  <a:srgbClr val="445577"/>
+                </a:solidFill>
+              </a:rPr>
+              <a:t> </a:t>
+            </a:r>
+            <a:r>
+              <a:rPr sz="1400" b="1" dirty="0" err="1">
+                <a:solidFill>
+                  <a:srgbClr val="445577"/>
+                </a:solidFill>
+              </a:rPr>
+              <a:t>захист</a:t>
+            </a:r>
+            <a:r>
+              <a:rPr sz="1400" b="1" dirty="0">
+                <a:solidFill>
+                  <a:srgbClr val="445577"/>
+                </a:solidFill>
+              </a:rPr>
+              <a:t> </a:t>
+            </a:r>
+            <a:r>
+              <a:rPr sz="1400" b="1" dirty="0" err="1">
+                <a:solidFill>
+                  <a:srgbClr val="445577"/>
+                </a:solidFill>
+              </a:rPr>
+              <a:t>у</a:t>
+            </a:r>
+            <a:r>
+              <a:rPr sz="1400" b="1" dirty="0">
+                <a:solidFill>
+                  <a:srgbClr val="445577"/>
+                </a:solidFill>
+              </a:rPr>
+              <a:t> </a:t>
+            </a:r>
+            <a:r>
+              <a:rPr sz="1400" b="1" dirty="0" err="1">
+                <a:solidFill>
+                  <a:srgbClr val="445577"/>
+                </a:solidFill>
+              </a:rPr>
+              <a:t>глибину</a:t>
+            </a:r>
+            <a:endParaRPr sz="1400" b="1" dirty="0">
+              <a:solidFill>
+                <a:srgbClr val="445577"/>
+              </a:solidFill>
+            </a:endParaRPr>
           </a:p>
         </p:txBody>
       </p:sp>
@@ -14145,8 +15315,8 @@
         </p:nvSpPr>
         <p:spPr>
           <a:xfrm>
-            <a:off x="2077720" y="349225"/>
-            <a:ext cx="3571240" cy="1325563"/>
+            <a:off x="1307805" y="349225"/>
+            <a:ext cx="4341155" cy="1325563"/>
           </a:xfrm>
         </p:spPr>
         <p:txBody>
@@ -14258,63 +15428,448 @@
           <a:lstStyle/>
           <a:p>
             <a:r>
-              <a:rPr sz="1300">
+              <a:rPr dirty="0">
                 <a:solidFill>
                   <a:srgbClr val="222233"/>
                 </a:solidFill>
               </a:rPr>
-              <a:t>•  Безпека: закони квантової фізики</a:t>
-            </a:r>
-          </a:p>
-          <a:p>
-            <a:r>
-              <a:rPr sz="1300">
+              <a:t>•  </a:t>
+            </a:r>
+            <a:r>
+              <a:rPr dirty="0" err="1">
                 <a:solidFill>
                   <a:srgbClr val="222233"/>
                 </a:solidFill>
               </a:rPr>
-              <a:t>•  Потребує фізичний квантовий канал</a:t>
-            </a:r>
-          </a:p>
-          <a:p>
-            <a:r>
-              <a:rPr sz="1300">
+              <a:t>Безпека</a:t>
+            </a:r>
+            <a:r>
+              <a:rPr dirty="0">
                 <a:solidFill>
                   <a:srgbClr val="222233"/>
                 </a:solidFill>
               </a:rPr>
-              <a:t>•  Дальність: до ~400 км (оптика), супутник</a:t>
-            </a:r>
-          </a:p>
-          <a:p>
-            <a:r>
-              <a:rPr sz="1300">
+              <a:t>: </a:t>
+            </a:r>
+            <a:r>
+              <a:rPr dirty="0" err="1">
                 <a:solidFill>
                   <a:srgbClr val="222233"/>
                 </a:solidFill>
               </a:rPr>
-              <a:t>•  Швидкість: десятки кбіт/с — Мбіт/с</a:t>
-            </a:r>
-          </a:p>
-          <a:p>
-            <a:r>
-              <a:rPr sz="1300">
+              <a:t>закони</a:t>
+            </a:r>
+            <a:r>
+              <a:rPr dirty="0">
                 <a:solidFill>
                   <a:srgbClr val="222233"/>
                 </a:solidFill>
               </a:rPr>
-              <a:t>•  Інфраструктура: спец. обладнання, $$$</a:t>
-            </a:r>
-          </a:p>
-          <a:p>
-            <a:r>
-              <a:rPr sz="1300">
+              <a:t> </a:t>
+            </a:r>
+            <a:r>
+              <a:rPr dirty="0" err="1">
                 <a:solidFill>
                   <a:srgbClr val="222233"/>
                 </a:solidFill>
               </a:rPr>
-              <a:t>•  Застосування: бекбон, держсектор</a:t>
-            </a:r>
+              <a:t>квантової</a:t>
+            </a:r>
+            <a:r>
+              <a:rPr dirty="0">
+                <a:solidFill>
+                  <a:srgbClr val="222233"/>
+                </a:solidFill>
+              </a:rPr>
+              <a:t> </a:t>
+            </a:r>
+            <a:r>
+              <a:rPr dirty="0" err="1">
+                <a:solidFill>
+                  <a:srgbClr val="222233"/>
+                </a:solidFill>
+              </a:rPr>
+              <a:t>фізики</a:t>
+            </a:r>
+            <a:endParaRPr dirty="0">
+              <a:solidFill>
+                <a:srgbClr val="222233"/>
+              </a:solidFill>
+            </a:endParaRPr>
+          </a:p>
+          <a:p>
+            <a:r>
+              <a:rPr dirty="0">
+                <a:solidFill>
+                  <a:srgbClr val="222233"/>
+                </a:solidFill>
+              </a:rPr>
+              <a:t>•  </a:t>
+            </a:r>
+            <a:r>
+              <a:rPr dirty="0" err="1">
+                <a:solidFill>
+                  <a:srgbClr val="222233"/>
+                </a:solidFill>
+              </a:rPr>
+              <a:t>Потребує</a:t>
+            </a:r>
+            <a:r>
+              <a:rPr dirty="0">
+                <a:solidFill>
+                  <a:srgbClr val="222233"/>
+                </a:solidFill>
+              </a:rPr>
+              <a:t> </a:t>
+            </a:r>
+            <a:r>
+              <a:rPr dirty="0" err="1">
+                <a:solidFill>
+                  <a:srgbClr val="222233"/>
+                </a:solidFill>
+              </a:rPr>
+              <a:t>фізичний</a:t>
+            </a:r>
+            <a:r>
+              <a:rPr dirty="0">
+                <a:solidFill>
+                  <a:srgbClr val="222233"/>
+                </a:solidFill>
+              </a:rPr>
+              <a:t> </a:t>
+            </a:r>
+            <a:r>
+              <a:rPr dirty="0" err="1">
+                <a:solidFill>
+                  <a:srgbClr val="222233"/>
+                </a:solidFill>
+              </a:rPr>
+              <a:t>квантовий</a:t>
+            </a:r>
+            <a:r>
+              <a:rPr dirty="0">
+                <a:solidFill>
+                  <a:srgbClr val="222233"/>
+                </a:solidFill>
+              </a:rPr>
+              <a:t> </a:t>
+            </a:r>
+            <a:r>
+              <a:rPr dirty="0" err="1">
+                <a:solidFill>
+                  <a:srgbClr val="222233"/>
+                </a:solidFill>
+              </a:rPr>
+              <a:t>канал</a:t>
+            </a:r>
+            <a:endParaRPr dirty="0">
+              <a:solidFill>
+                <a:srgbClr val="222233"/>
+              </a:solidFill>
+            </a:endParaRPr>
+          </a:p>
+          <a:p>
+            <a:r>
+              <a:rPr dirty="0">
+                <a:solidFill>
+                  <a:srgbClr val="222233"/>
+                </a:solidFill>
+              </a:rPr>
+              <a:t>•  </a:t>
+            </a:r>
+            <a:r>
+              <a:rPr dirty="0" err="1">
+                <a:solidFill>
+                  <a:srgbClr val="222233"/>
+                </a:solidFill>
+              </a:rPr>
+              <a:t>Дальність</a:t>
+            </a:r>
+            <a:r>
+              <a:rPr dirty="0">
+                <a:solidFill>
+                  <a:srgbClr val="222233"/>
+                </a:solidFill>
+              </a:rPr>
+              <a:t>: </a:t>
+            </a:r>
+            <a:r>
+              <a:rPr dirty="0" err="1">
+                <a:solidFill>
+                  <a:srgbClr val="222233"/>
+                </a:solidFill>
+              </a:rPr>
+              <a:t>до</a:t>
+            </a:r>
+            <a:r>
+              <a:rPr dirty="0">
+                <a:solidFill>
+                  <a:srgbClr val="222233"/>
+                </a:solidFill>
+              </a:rPr>
+              <a:t> ~400 </a:t>
+            </a:r>
+            <a:r>
+              <a:rPr dirty="0" err="1">
+                <a:solidFill>
+                  <a:srgbClr val="222233"/>
+                </a:solidFill>
+              </a:rPr>
+              <a:t>км</a:t>
+            </a:r>
+            <a:r>
+              <a:rPr dirty="0">
+                <a:solidFill>
+                  <a:srgbClr val="222233"/>
+                </a:solidFill>
+              </a:rPr>
+              <a:t> (</a:t>
+            </a:r>
+            <a:r>
+              <a:rPr dirty="0" err="1">
+                <a:solidFill>
+                  <a:srgbClr val="222233"/>
+                </a:solidFill>
+              </a:rPr>
+              <a:t>оптика</a:t>
+            </a:r>
+            <a:r>
+              <a:rPr dirty="0">
+                <a:solidFill>
+                  <a:srgbClr val="222233"/>
+                </a:solidFill>
+              </a:rPr>
+              <a:t>), </a:t>
+            </a:r>
+            <a:r>
+              <a:rPr dirty="0" err="1">
+                <a:solidFill>
+                  <a:srgbClr val="222233"/>
+                </a:solidFill>
+              </a:rPr>
+              <a:t>супутник</a:t>
+            </a:r>
+            <a:endParaRPr dirty="0">
+              <a:solidFill>
+                <a:srgbClr val="222233"/>
+              </a:solidFill>
+            </a:endParaRPr>
+          </a:p>
+          <a:p>
+            <a:r>
+              <a:rPr dirty="0">
+                <a:solidFill>
+                  <a:srgbClr val="222233"/>
+                </a:solidFill>
+              </a:rPr>
+              <a:t>•  </a:t>
+            </a:r>
+            <a:r>
+              <a:rPr dirty="0" err="1">
+                <a:solidFill>
+                  <a:srgbClr val="222233"/>
+                </a:solidFill>
+              </a:rPr>
+              <a:t>Швидкість</a:t>
+            </a:r>
+            <a:r>
+              <a:rPr dirty="0">
+                <a:solidFill>
+                  <a:srgbClr val="222233"/>
+                </a:solidFill>
+              </a:rPr>
+              <a:t>: </a:t>
+            </a:r>
+            <a:r>
+              <a:rPr dirty="0" err="1">
+                <a:solidFill>
+                  <a:srgbClr val="222233"/>
+                </a:solidFill>
+              </a:rPr>
+              <a:t>десятки</a:t>
+            </a:r>
+            <a:r>
+              <a:rPr dirty="0">
+                <a:solidFill>
+                  <a:srgbClr val="222233"/>
+                </a:solidFill>
+              </a:rPr>
+              <a:t> </a:t>
+            </a:r>
+            <a:r>
+              <a:rPr dirty="0" err="1">
+                <a:solidFill>
+                  <a:srgbClr val="222233"/>
+                </a:solidFill>
+              </a:rPr>
+              <a:t>кбіт</a:t>
+            </a:r>
+            <a:r>
+              <a:rPr dirty="0">
+                <a:solidFill>
+                  <a:srgbClr val="222233"/>
+                </a:solidFill>
+              </a:rPr>
+              <a:t>/</a:t>
+            </a:r>
+            <a:r>
+              <a:rPr dirty="0" err="1">
+                <a:solidFill>
+                  <a:srgbClr val="222233"/>
+                </a:solidFill>
+              </a:rPr>
+              <a:t>с</a:t>
+            </a:r>
+            <a:r>
+              <a:rPr dirty="0">
+                <a:solidFill>
+                  <a:srgbClr val="222233"/>
+                </a:solidFill>
+              </a:rPr>
+              <a:t> — </a:t>
+            </a:r>
+            <a:r>
+              <a:rPr dirty="0" err="1">
+                <a:solidFill>
+                  <a:srgbClr val="222233"/>
+                </a:solidFill>
+              </a:rPr>
+              <a:t>Мбіт</a:t>
+            </a:r>
+            <a:r>
+              <a:rPr dirty="0">
+                <a:solidFill>
+                  <a:srgbClr val="222233"/>
+                </a:solidFill>
+              </a:rPr>
+              <a:t>/</a:t>
+            </a:r>
+            <a:r>
+              <a:rPr dirty="0" err="1">
+                <a:solidFill>
+                  <a:srgbClr val="222233"/>
+                </a:solidFill>
+              </a:rPr>
+              <a:t>с</a:t>
+            </a:r>
+            <a:endParaRPr dirty="0">
+              <a:solidFill>
+                <a:srgbClr val="222233"/>
+              </a:solidFill>
+            </a:endParaRPr>
+          </a:p>
+          <a:p>
+            <a:r>
+              <a:rPr dirty="0">
+                <a:solidFill>
+                  <a:srgbClr val="222233"/>
+                </a:solidFill>
+              </a:rPr>
+              <a:t>•  </a:t>
+            </a:r>
+            <a:r>
+              <a:rPr dirty="0" err="1">
+                <a:solidFill>
+                  <a:srgbClr val="222233"/>
+                </a:solidFill>
+              </a:rPr>
+              <a:t>Інфраструктура</a:t>
+            </a:r>
+            <a:r>
+              <a:rPr dirty="0">
+                <a:solidFill>
+                  <a:srgbClr val="222233"/>
+                </a:solidFill>
+              </a:rPr>
+              <a:t>: </a:t>
+            </a:r>
+            <a:r>
+              <a:rPr dirty="0" err="1">
+                <a:solidFill>
+                  <a:srgbClr val="222233"/>
+                </a:solidFill>
+              </a:rPr>
+              <a:t>спец</a:t>
+            </a:r>
+            <a:r>
+              <a:rPr dirty="0">
+                <a:solidFill>
+                  <a:srgbClr val="222233"/>
+                </a:solidFill>
+              </a:rPr>
+              <a:t>. </a:t>
+            </a:r>
+            <a:r>
+              <a:rPr dirty="0" err="1">
+                <a:solidFill>
+                  <a:srgbClr val="222233"/>
+                </a:solidFill>
+              </a:rPr>
+              <a:t>обладнання</a:t>
+            </a:r>
+            <a:r>
+              <a:rPr dirty="0">
+                <a:solidFill>
+                  <a:srgbClr val="222233"/>
+                </a:solidFill>
+              </a:rPr>
+              <a:t>, $$$</a:t>
+            </a:r>
+          </a:p>
+          <a:p>
+            <a:r>
+              <a:rPr dirty="0">
+                <a:solidFill>
+                  <a:srgbClr val="222233"/>
+                </a:solidFill>
+              </a:rPr>
+              <a:t>•  </a:t>
+            </a:r>
+            <a:r>
+              <a:rPr dirty="0" err="1">
+                <a:solidFill>
+                  <a:srgbClr val="222233"/>
+                </a:solidFill>
+              </a:rPr>
+              <a:t>Застосування</a:t>
+            </a:r>
+            <a:r>
+              <a:rPr dirty="0">
+                <a:solidFill>
+                  <a:srgbClr val="222233"/>
+                </a:solidFill>
+              </a:rPr>
+              <a:t>: </a:t>
+            </a:r>
+            <a:r>
+              <a:rPr dirty="0" err="1">
+                <a:solidFill>
+                  <a:srgbClr val="222233"/>
+                </a:solidFill>
+              </a:rPr>
+              <a:t>бекбон</a:t>
+            </a:r>
+            <a:r>
+              <a:rPr dirty="0">
+                <a:solidFill>
+                  <a:srgbClr val="222233"/>
+                </a:solidFill>
+              </a:rPr>
+              <a:t>, </a:t>
+            </a:r>
+            <a:r>
+              <a:rPr dirty="0" err="1">
+                <a:solidFill>
+                  <a:srgbClr val="222233"/>
+                </a:solidFill>
+              </a:rPr>
+              <a:t>держсектор</a:t>
+            </a:r>
+            <a:endParaRPr dirty="0">
+              <a:solidFill>
+                <a:srgbClr val="222233"/>
+              </a:solidFill>
+            </a:endParaRPr>
           </a:p>
         </p:txBody>
       </p:sp>
@@ -14413,7 +15968,7 @@
           <a:lstStyle/>
           <a:p>
             <a:r>
-              <a:rPr sz="1300">
+              <a:rPr>
                 <a:solidFill>
                   <a:srgbClr val="222233"/>
                 </a:solidFill>
@@ -14423,7 +15978,7 @@
           </a:p>
           <a:p>
             <a:r>
-              <a:rPr sz="1300">
+              <a:rPr>
                 <a:solidFill>
                   <a:srgbClr val="222233"/>
                 </a:solidFill>
@@ -14433,7 +15988,7 @@
           </a:p>
           <a:p>
             <a:r>
-              <a:rPr sz="1300">
+              <a:rPr>
                 <a:solidFill>
                   <a:srgbClr val="222233"/>
                 </a:solidFill>
@@ -14443,7 +15998,7 @@
           </a:p>
           <a:p>
             <a:r>
-              <a:rPr sz="1300">
+              <a:rPr>
                 <a:solidFill>
                   <a:srgbClr val="222233"/>
                 </a:solidFill>
@@ -14453,7 +16008,7 @@
           </a:p>
           <a:p>
             <a:r>
-              <a:rPr sz="1300">
+              <a:rPr>
                 <a:solidFill>
                   <a:srgbClr val="222233"/>
                 </a:solidFill>
@@ -14463,7 +16018,7 @@
           </a:p>
           <a:p>
             <a:r>
-              <a:rPr sz="1300">
+              <a:rPr>
                 <a:solidFill>
                   <a:srgbClr val="222233"/>
                 </a:solidFill>

</xml_diff>